<commit_message>
Update investment committee deck with validation gains
</commit_message>
<xml_diff>
--- a/reports/presentations/wolf_investment_principal/wolf_quant_model_ic_briefing.pptx
+++ b/reports/presentations/wolf_investment_principal/wolf_quant_model_ic_briefing.pptx
@@ -3653,7 +3653,7 @@
       </p:sp>
       <p:sp>
         <p:nvSpPr>
-          <p:cNvPr id="15" name="Text: 80 / 100"/>
+          <p:cNvPr id="15" name="Text: 87.5 / 100"/>
           <p:cNvSpPr txBox="1"/>
           <p:nvPr/>
         </p:nvSpPr>
@@ -3685,7 +3685,7 @@
                 </a:solidFill>
                 <a:latin typeface="Aptos Display"/>
               </a:rPr>
-              <a:t>80 / 100</a:t>
+              <a:t>87.5 / 100</a:t>
             </a:r>
           </a:p>
         </p:txBody>
@@ -3854,7 +3854,7 @@
       </p:sp>
       <p:sp>
         <p:nvSpPr>
-          <p:cNvPr id="20" name="Text: As of 12 August 2026  |  CONDITIONALLY_APPROVED  |"/>
+          <p:cNvPr id="20" name="Text: As of 13 August 2026  |  CONDITIONALLY_APPROVED  |"/>
           <p:cNvSpPr txBox="1"/>
           <p:nvPr/>
         </p:nvSpPr>
@@ -3886,7 +3886,7 @@
                 </a:solidFill>
                 <a:latin typeface="Aptos"/>
               </a:rPr>
-              <a:t>As of 12 August 2026  |  CONDITIONALLY_APPROVED  |  Research evidence</a:t>
+              <a:t>As of 13 August 2026  |  CONDITIONALLY_APPROVED  |  Research evidence</a:t>
             </a:r>
           </a:p>
         </p:txBody>
@@ -7721,7 +7721,7 @@
       <p:grpSpPr/>
       <p:sp>
         <p:nvSpPr>
-          <p:cNvPr id="2" name="Text: Governance is conditional, not failed"/>
+          <p:cNvPr id="2" name="Text: Risk calibration now passes; approval stays condit"/>
           <p:cNvSpPr txBox="1"/>
           <p:nvPr/>
         </p:nvSpPr>
@@ -7753,14 +7753,14 @@
                 </a:solidFill>
                 <a:latin typeface="Aptos Display"/>
               </a:rPr>
-              <a:t>Governance is conditional, not failed</a:t>
-            </a:r>
-          </a:p>
-        </p:txBody>
-      </p:sp>
-      <p:sp>
-        <p:nvSpPr>
-          <p:cNvPr id="3" name="Text: The model passed core controls but still carries t"/>
+              <a:t>Risk calibration now passes; approval stays conditional</a:t>
+            </a:r>
+          </a:p>
+        </p:txBody>
+      </p:sp>
+      <p:sp>
+        <p:nvSpPr>
+          <p:cNvPr id="3" name="Text: Adaptive VaR fixed exception clustering without hi"/>
           <p:cNvSpPr txBox="1"/>
           <p:nvPr/>
         </p:nvSpPr>
@@ -7792,7 +7792,7 @@
                 </a:solidFill>
                 <a:latin typeface="Aptos"/>
               </a:rPr>
-              <a:t>The model passed core controls but still carries three warning areas.</a:t>
+              <a:t>Adaptive VaR fixed exception clustering without hiding PIT and alpha limits.</a:t>
             </a:r>
           </a:p>
         </p:txBody>
@@ -7922,7 +7922,7 @@
       </p:sp>
       <p:sp>
         <p:nvSpPr>
-          <p:cNvPr id="7" name="Text: Model validation scorecard and risk backtesting re"/>
+          <p:cNvPr id="7" name="Text: Validation scorecard and overall/holdout VaR tests"/>
           <p:cNvSpPr txBox="1"/>
           <p:nvPr/>
         </p:nvSpPr>
@@ -7954,7 +7954,7 @@
                 </a:solidFill>
                 <a:latin typeface="Aptos"/>
               </a:rPr>
-              <a:t>Model validation scorecard and risk backtesting report</a:t>
+              <a:t>Validation scorecard and overall/holdout VaR tests</a:t>
             </a:r>
           </a:p>
         </p:txBody>
@@ -7975,8 +7975,8 @@
         </p:blipFill>
         <p:spPr>
           <a:xfrm>
-            <a:off x="438912" y="1562537"/>
-            <a:ext cx="6784848" cy="3915804"/>
+            <a:off x="393192" y="1871263"/>
+            <a:ext cx="5715000" cy="3298353"/>
           </a:xfrm>
           <a:prstGeom prst="rect">
             <a:avLst/>
@@ -7985,14 +7985,692 @@
       </p:pic>
       <p:sp>
         <p:nvSpPr>
-          <p:cNvPr id="9" name="Rectangle 8"/>
+          <p:cNvPr id="9" name="Text: VaR coverage and independence"/>
+          <p:cNvSpPr txBox="1"/>
+          <p:nvPr/>
+        </p:nvSpPr>
+        <p:spPr>
+          <a:xfrm>
+            <a:off x="6345936" y="1353312"/>
+            <a:ext cx="5029200" cy="310896"/>
+          </a:xfrm>
+          <a:prstGeom prst="rect">
+            <a:avLst/>
+          </a:prstGeom>
+          <a:noFill/>
+        </p:spPr>
+        <p:txBody>
+          <a:bodyPr wrap="square" anchor="t" lIns="18288" rIns="18288" tIns="18288" bIns="18288">
+            <a:spAutoFit/>
+          </a:bodyPr>
+          <a:lstStyle/>
+          <a:p>
+            <a:pPr algn="l">
+              <a:spcAft>
+                <a:spcPts val="0"/>
+              </a:spcAft>
+            </a:pPr>
+            <a:r>
+              <a:rPr sz="1800" b="1">
+                <a:solidFill>
+                  <a:srgbClr val="172127"/>
+                </a:solidFill>
+                <a:latin typeface="Aptos Display"/>
+              </a:rPr>
+              <a:t>VaR coverage and independence</a:t>
+            </a:r>
+          </a:p>
+        </p:txBody>
+      </p:sp>
+      <p:graphicFrame>
+        <p:nvGraphicFramePr>
+          <p:cNvPr id="10" name="Evidence table"/>
+          <p:cNvGraphicFramePr>
+            <a:graphicFrameLocks noGrp="1"/>
+          </p:cNvGraphicFramePr>
+          <p:nvPr/>
+        </p:nvGraphicFramePr>
+        <p:xfrm>
+          <a:off x="6336792" y="1773936"/>
+          <a:ext cx="5340092" cy="2176272"/>
+        </p:xfrm>
+        <a:graphic>
+          <a:graphicData uri="http://schemas.openxmlformats.org/drawingml/2006/table">
+            <a:tbl>
+              <a:tblPr firstRow="1" bandRow="1">
+                <a:tableStyleId>{5C22544A-7EE6-4342-B048-85BDC9FD1C3A}</a:tableStyleId>
+              </a:tblPr>
+              <a:tblGrid>
+                <a:gridCol w="1320668"/>
+                <a:gridCol w="780917"/>
+                <a:gridCol w="1171375"/>
+                <a:gridCol w="1033566"/>
+                <a:gridCol w="1033566"/>
+              </a:tblGrid>
+              <a:tr h="435254">
+                <a:tc>
+                  <a:txBody>
+                    <a:bodyPr/>
+                    <a:lstStyle/>
+                    <a:p>
+                      <a:pPr algn="l">
+                        <a:defRPr sz="919" b="1">
+                          <a:solidFill>
+                            <a:srgbClr val="FFFFFF"/>
+                          </a:solidFill>
+                          <a:latin typeface="Aptos"/>
+                        </a:defRPr>
+                      </a:pPr>
+                      <a:r>
+                        <a:t>Sample</a:t>
+                      </a:r>
+                    </a:p>
+                  </a:txBody>
+                  <a:tcPr marL="54864" marR="36576" marT="27432" marB="27432">
+                    <a:solidFill>
+                      <a:srgbClr val="172127"/>
+                    </a:solidFill>
+                  </a:tcPr>
+                </a:tc>
+                <a:tc>
+                  <a:txBody>
+                    <a:bodyPr/>
+                    <a:lstStyle/>
+                    <a:p>
+                      <a:pPr algn="l">
+                        <a:defRPr sz="919" b="1">
+                          <a:solidFill>
+                            <a:srgbClr val="FFFFFF"/>
+                          </a:solidFill>
+                          <a:latin typeface="Aptos"/>
+                        </a:defRPr>
+                      </a:pPr>
+                      <a:r>
+                        <a:t>VaR</a:t>
+                      </a:r>
+                    </a:p>
+                  </a:txBody>
+                  <a:tcPr marL="54864" marR="36576" marT="27432" marB="27432">
+                    <a:solidFill>
+                      <a:srgbClr val="172127"/>
+                    </a:solidFill>
+                  </a:tcPr>
+                </a:tc>
+                <a:tc>
+                  <a:txBody>
+                    <a:bodyPr/>
+                    <a:lstStyle/>
+                    <a:p>
+                      <a:pPr algn="l">
+                        <a:defRPr sz="919" b="1">
+                          <a:solidFill>
+                            <a:srgbClr val="FFFFFF"/>
+                          </a:solidFill>
+                          <a:latin typeface="Aptos"/>
+                        </a:defRPr>
+                      </a:pPr>
+                      <a:r>
+                        <a:t>Exceptions</a:t>
+                      </a:r>
+                    </a:p>
+                  </a:txBody>
+                  <a:tcPr marL="54864" marR="36576" marT="27432" marB="27432">
+                    <a:solidFill>
+                      <a:srgbClr val="172127"/>
+                    </a:solidFill>
+                  </a:tcPr>
+                </a:tc>
+                <a:tc>
+                  <a:txBody>
+                    <a:bodyPr/>
+                    <a:lstStyle/>
+                    <a:p>
+                      <a:pPr algn="l">
+                        <a:defRPr sz="919" b="1">
+                          <a:solidFill>
+                            <a:srgbClr val="FFFFFF"/>
+                          </a:solidFill>
+                          <a:latin typeface="Aptos"/>
+                        </a:defRPr>
+                      </a:pPr>
+                      <a:r>
+                        <a:t>Kupiec p</a:t>
+                      </a:r>
+                    </a:p>
+                  </a:txBody>
+                  <a:tcPr marL="54864" marR="36576" marT="27432" marB="27432">
+                    <a:solidFill>
+                      <a:srgbClr val="172127"/>
+                    </a:solidFill>
+                  </a:tcPr>
+                </a:tc>
+                <a:tc>
+                  <a:txBody>
+                    <a:bodyPr/>
+                    <a:lstStyle/>
+                    <a:p>
+                      <a:pPr algn="l">
+                        <a:defRPr sz="919" b="1">
+                          <a:solidFill>
+                            <a:srgbClr val="FFFFFF"/>
+                          </a:solidFill>
+                          <a:latin typeface="Aptos"/>
+                        </a:defRPr>
+                      </a:pPr>
+                      <a:r>
+                        <a:t>Indep. p</a:t>
+                      </a:r>
+                    </a:p>
+                  </a:txBody>
+                  <a:tcPr marL="54864" marR="36576" marT="27432" marB="27432">
+                    <a:solidFill>
+                      <a:srgbClr val="172127"/>
+                    </a:solidFill>
+                  </a:tcPr>
+                </a:tc>
+              </a:tr>
+              <a:tr h="435254">
+                <a:tc>
+                  <a:txBody>
+                    <a:bodyPr/>
+                    <a:lstStyle/>
+                    <a:p>
+                      <a:pPr algn="l">
+                        <a:defRPr sz="919">
+                          <a:solidFill>
+                            <a:srgbClr val="172127"/>
+                          </a:solidFill>
+                          <a:latin typeface="Aptos"/>
+                        </a:defRPr>
+                      </a:pPr>
+                      <a:r>
+                        <a:t>Overall</a:t>
+                      </a:r>
+                    </a:p>
+                  </a:txBody>
+                  <a:tcPr marL="54864" marR="36576" marT="22860" marB="22860">
+                    <a:solidFill>
+                      <a:srgbClr val="E8F4EF"/>
+                    </a:solidFill>
+                  </a:tcPr>
+                </a:tc>
+                <a:tc>
+                  <a:txBody>
+                    <a:bodyPr/>
+                    <a:lstStyle/>
+                    <a:p>
+                      <a:pPr algn="l">
+                        <a:defRPr sz="919">
+                          <a:solidFill>
+                            <a:srgbClr val="172127"/>
+                          </a:solidFill>
+                          <a:latin typeface="Aptos"/>
+                        </a:defRPr>
+                      </a:pPr>
+                      <a:r>
+                        <a:t>95%</a:t>
+                      </a:r>
+                    </a:p>
+                  </a:txBody>
+                  <a:tcPr marL="54864" marR="36576" marT="22860" marB="22860">
+                    <a:solidFill>
+                      <a:srgbClr val="E8F4EF"/>
+                    </a:solidFill>
+                  </a:tcPr>
+                </a:tc>
+                <a:tc>
+                  <a:txBody>
+                    <a:bodyPr/>
+                    <a:lstStyle/>
+                    <a:p>
+                      <a:pPr algn="r">
+                        <a:defRPr sz="919">
+                          <a:solidFill>
+                            <a:srgbClr val="172127"/>
+                          </a:solidFill>
+                          <a:latin typeface="Aptos"/>
+                        </a:defRPr>
+                      </a:pPr>
+                      <a:r>
+                        <a:t>62/1152</a:t>
+                      </a:r>
+                    </a:p>
+                  </a:txBody>
+                  <a:tcPr marL="54864" marR="36576" marT="22860" marB="22860">
+                    <a:solidFill>
+                      <a:srgbClr val="E8F4EF"/>
+                    </a:solidFill>
+                  </a:tcPr>
+                </a:tc>
+                <a:tc>
+                  <a:txBody>
+                    <a:bodyPr/>
+                    <a:lstStyle/>
+                    <a:p>
+                      <a:pPr algn="r">
+                        <a:defRPr sz="919">
+                          <a:solidFill>
+                            <a:srgbClr val="172127"/>
+                          </a:solidFill>
+                          <a:latin typeface="Aptos"/>
+                        </a:defRPr>
+                      </a:pPr>
+                      <a:r>
+                        <a:t>0.557</a:t>
+                      </a:r>
+                    </a:p>
+                  </a:txBody>
+                  <a:tcPr marL="54864" marR="36576" marT="22860" marB="22860">
+                    <a:solidFill>
+                      <a:srgbClr val="E8F4EF"/>
+                    </a:solidFill>
+                  </a:tcPr>
+                </a:tc>
+                <a:tc>
+                  <a:txBody>
+                    <a:bodyPr/>
+                    <a:lstStyle/>
+                    <a:p>
+                      <a:pPr algn="r">
+                        <a:defRPr sz="919">
+                          <a:solidFill>
+                            <a:srgbClr val="172127"/>
+                          </a:solidFill>
+                          <a:latin typeface="Aptos"/>
+                        </a:defRPr>
+                      </a:pPr>
+                      <a:r>
+                        <a:t>0.367</a:t>
+                      </a:r>
+                    </a:p>
+                  </a:txBody>
+                  <a:tcPr marL="54864" marR="36576" marT="22860" marB="22860">
+                    <a:solidFill>
+                      <a:srgbClr val="E8F4EF"/>
+                    </a:solidFill>
+                  </a:tcPr>
+                </a:tc>
+              </a:tr>
+              <a:tr h="435254">
+                <a:tc>
+                  <a:txBody>
+                    <a:bodyPr/>
+                    <a:lstStyle/>
+                    <a:p>
+                      <a:pPr algn="l">
+                        <a:defRPr sz="919">
+                          <a:solidFill>
+                            <a:srgbClr val="172127"/>
+                          </a:solidFill>
+                          <a:latin typeface="Aptos"/>
+                        </a:defRPr>
+                      </a:pPr>
+                      <a:r>
+                        <a:t>Overall</a:t>
+                      </a:r>
+                    </a:p>
+                  </a:txBody>
+                  <a:tcPr marL="54864" marR="36576" marT="22860" marB="22860">
+                    <a:solidFill>
+                      <a:srgbClr val="E8F4EF"/>
+                    </a:solidFill>
+                  </a:tcPr>
+                </a:tc>
+                <a:tc>
+                  <a:txBody>
+                    <a:bodyPr/>
+                    <a:lstStyle/>
+                    <a:p>
+                      <a:pPr algn="l">
+                        <a:defRPr sz="919">
+                          <a:solidFill>
+                            <a:srgbClr val="172127"/>
+                          </a:solidFill>
+                          <a:latin typeface="Aptos"/>
+                        </a:defRPr>
+                      </a:pPr>
+                      <a:r>
+                        <a:t>99%</a:t>
+                      </a:r>
+                    </a:p>
+                  </a:txBody>
+                  <a:tcPr marL="54864" marR="36576" marT="22860" marB="22860">
+                    <a:solidFill>
+                      <a:srgbClr val="E8F4EF"/>
+                    </a:solidFill>
+                  </a:tcPr>
+                </a:tc>
+                <a:tc>
+                  <a:txBody>
+                    <a:bodyPr/>
+                    <a:lstStyle/>
+                    <a:p>
+                      <a:pPr algn="r">
+                        <a:defRPr sz="919">
+                          <a:solidFill>
+                            <a:srgbClr val="172127"/>
+                          </a:solidFill>
+                          <a:latin typeface="Aptos"/>
+                        </a:defRPr>
+                      </a:pPr>
+                      <a:r>
+                        <a:t>10/1152</a:t>
+                      </a:r>
+                    </a:p>
+                  </a:txBody>
+                  <a:tcPr marL="54864" marR="36576" marT="22860" marB="22860">
+                    <a:solidFill>
+                      <a:srgbClr val="E8F4EF"/>
+                    </a:solidFill>
+                  </a:tcPr>
+                </a:tc>
+                <a:tc>
+                  <a:txBody>
+                    <a:bodyPr/>
+                    <a:lstStyle/>
+                    <a:p>
+                      <a:pPr algn="r">
+                        <a:defRPr sz="919">
+                          <a:solidFill>
+                            <a:srgbClr val="172127"/>
+                          </a:solidFill>
+                          <a:latin typeface="Aptos"/>
+                        </a:defRPr>
+                      </a:pPr>
+                      <a:r>
+                        <a:t>0.645</a:t>
+                      </a:r>
+                    </a:p>
+                  </a:txBody>
+                  <a:tcPr marL="54864" marR="36576" marT="22860" marB="22860">
+                    <a:solidFill>
+                      <a:srgbClr val="E8F4EF"/>
+                    </a:solidFill>
+                  </a:tcPr>
+                </a:tc>
+                <a:tc>
+                  <a:txBody>
+                    <a:bodyPr/>
+                    <a:lstStyle/>
+                    <a:p>
+                      <a:pPr algn="r">
+                        <a:defRPr sz="919">
+                          <a:solidFill>
+                            <a:srgbClr val="172127"/>
+                          </a:solidFill>
+                          <a:latin typeface="Aptos"/>
+                        </a:defRPr>
+                      </a:pPr>
+                      <a:r>
+                        <a:t>0.072</a:t>
+                      </a:r>
+                    </a:p>
+                  </a:txBody>
+                  <a:tcPr marL="54864" marR="36576" marT="22860" marB="22860">
+                    <a:solidFill>
+                      <a:srgbClr val="E8F4EF"/>
+                    </a:solidFill>
+                  </a:tcPr>
+                </a:tc>
+              </a:tr>
+              <a:tr h="435254">
+                <a:tc>
+                  <a:txBody>
+                    <a:bodyPr/>
+                    <a:lstStyle/>
+                    <a:p>
+                      <a:pPr algn="l">
+                        <a:defRPr sz="919">
+                          <a:solidFill>
+                            <a:srgbClr val="172127"/>
+                          </a:solidFill>
+                          <a:latin typeface="Aptos"/>
+                        </a:defRPr>
+                      </a:pPr>
+                      <a:r>
+                        <a:t>Holdout</a:t>
+                      </a:r>
+                    </a:p>
+                  </a:txBody>
+                  <a:tcPr marL="54864" marR="36576" marT="22860" marB="22860">
+                    <a:solidFill>
+                      <a:srgbClr val="E8F4EF"/>
+                    </a:solidFill>
+                  </a:tcPr>
+                </a:tc>
+                <a:tc>
+                  <a:txBody>
+                    <a:bodyPr/>
+                    <a:lstStyle/>
+                    <a:p>
+                      <a:pPr algn="l">
+                        <a:defRPr sz="919">
+                          <a:solidFill>
+                            <a:srgbClr val="172127"/>
+                          </a:solidFill>
+                          <a:latin typeface="Aptos"/>
+                        </a:defRPr>
+                      </a:pPr>
+                      <a:r>
+                        <a:t>95%</a:t>
+                      </a:r>
+                    </a:p>
+                  </a:txBody>
+                  <a:tcPr marL="54864" marR="36576" marT="22860" marB="22860">
+                    <a:solidFill>
+                      <a:srgbClr val="E8F4EF"/>
+                    </a:solidFill>
+                  </a:tcPr>
+                </a:tc>
+                <a:tc>
+                  <a:txBody>
+                    <a:bodyPr/>
+                    <a:lstStyle/>
+                    <a:p>
+                      <a:pPr algn="r">
+                        <a:defRPr sz="919">
+                          <a:solidFill>
+                            <a:srgbClr val="172127"/>
+                          </a:solidFill>
+                          <a:latin typeface="Aptos"/>
+                        </a:defRPr>
+                      </a:pPr>
+                      <a:r>
+                        <a:t>21/460</a:t>
+                      </a:r>
+                    </a:p>
+                  </a:txBody>
+                  <a:tcPr marL="54864" marR="36576" marT="22860" marB="22860">
+                    <a:solidFill>
+                      <a:srgbClr val="E8F4EF"/>
+                    </a:solidFill>
+                  </a:tcPr>
+                </a:tc>
+                <a:tc>
+                  <a:txBody>
+                    <a:bodyPr/>
+                    <a:lstStyle/>
+                    <a:p>
+                      <a:pPr algn="r">
+                        <a:defRPr sz="919">
+                          <a:solidFill>
+                            <a:srgbClr val="172127"/>
+                          </a:solidFill>
+                          <a:latin typeface="Aptos"/>
+                        </a:defRPr>
+                      </a:pPr>
+                      <a:r>
+                        <a:t>0.664</a:t>
+                      </a:r>
+                    </a:p>
+                  </a:txBody>
+                  <a:tcPr marL="54864" marR="36576" marT="22860" marB="22860">
+                    <a:solidFill>
+                      <a:srgbClr val="E8F4EF"/>
+                    </a:solidFill>
+                  </a:tcPr>
+                </a:tc>
+                <a:tc>
+                  <a:txBody>
+                    <a:bodyPr/>
+                    <a:lstStyle/>
+                    <a:p>
+                      <a:pPr algn="r">
+                        <a:defRPr sz="919">
+                          <a:solidFill>
+                            <a:srgbClr val="172127"/>
+                          </a:solidFill>
+                          <a:latin typeface="Aptos"/>
+                        </a:defRPr>
+                      </a:pPr>
+                      <a:r>
+                        <a:t>0.074</a:t>
+                      </a:r>
+                    </a:p>
+                  </a:txBody>
+                  <a:tcPr marL="54864" marR="36576" marT="22860" marB="22860">
+                    <a:solidFill>
+                      <a:srgbClr val="E8F4EF"/>
+                    </a:solidFill>
+                  </a:tcPr>
+                </a:tc>
+              </a:tr>
+              <a:tr h="435256">
+                <a:tc>
+                  <a:txBody>
+                    <a:bodyPr/>
+                    <a:lstStyle/>
+                    <a:p>
+                      <a:pPr algn="l">
+                        <a:defRPr sz="919">
+                          <a:solidFill>
+                            <a:srgbClr val="172127"/>
+                          </a:solidFill>
+                          <a:latin typeface="Aptos"/>
+                        </a:defRPr>
+                      </a:pPr>
+                      <a:r>
+                        <a:t>Holdout</a:t>
+                      </a:r>
+                    </a:p>
+                  </a:txBody>
+                  <a:tcPr marL="54864" marR="36576" marT="22860" marB="22860">
+                    <a:solidFill>
+                      <a:srgbClr val="E8F4EF"/>
+                    </a:solidFill>
+                  </a:tcPr>
+                </a:tc>
+                <a:tc>
+                  <a:txBody>
+                    <a:bodyPr/>
+                    <a:lstStyle/>
+                    <a:p>
+                      <a:pPr algn="l">
+                        <a:defRPr sz="919">
+                          <a:solidFill>
+                            <a:srgbClr val="172127"/>
+                          </a:solidFill>
+                          <a:latin typeface="Aptos"/>
+                        </a:defRPr>
+                      </a:pPr>
+                      <a:r>
+                        <a:t>99%</a:t>
+                      </a:r>
+                    </a:p>
+                  </a:txBody>
+                  <a:tcPr marL="54864" marR="36576" marT="22860" marB="22860">
+                    <a:solidFill>
+                      <a:srgbClr val="E8F4EF"/>
+                    </a:solidFill>
+                  </a:tcPr>
+                </a:tc>
+                <a:tc>
+                  <a:txBody>
+                    <a:bodyPr/>
+                    <a:lstStyle/>
+                    <a:p>
+                      <a:pPr algn="r">
+                        <a:defRPr sz="919">
+                          <a:solidFill>
+                            <a:srgbClr val="172127"/>
+                          </a:solidFill>
+                          <a:latin typeface="Aptos"/>
+                        </a:defRPr>
+                      </a:pPr>
+                      <a:r>
+                        <a:t>3/460</a:t>
+                      </a:r>
+                    </a:p>
+                  </a:txBody>
+                  <a:tcPr marL="54864" marR="36576" marT="22860" marB="22860">
+                    <a:solidFill>
+                      <a:srgbClr val="E8F4EF"/>
+                    </a:solidFill>
+                  </a:tcPr>
+                </a:tc>
+                <a:tc>
+                  <a:txBody>
+                    <a:bodyPr/>
+                    <a:lstStyle/>
+                    <a:p>
+                      <a:pPr algn="r">
+                        <a:defRPr sz="919">
+                          <a:solidFill>
+                            <a:srgbClr val="172127"/>
+                          </a:solidFill>
+                          <a:latin typeface="Aptos"/>
+                        </a:defRPr>
+                      </a:pPr>
+                      <a:r>
+                        <a:t>0.423</a:t>
+                      </a:r>
+                    </a:p>
+                  </a:txBody>
+                  <a:tcPr marL="54864" marR="36576" marT="22860" marB="22860">
+                    <a:solidFill>
+                      <a:srgbClr val="E8F4EF"/>
+                    </a:solidFill>
+                  </a:tcPr>
+                </a:tc>
+                <a:tc>
+                  <a:txBody>
+                    <a:bodyPr/>
+                    <a:lstStyle/>
+                    <a:p>
+                      <a:pPr algn="r">
+                        <a:defRPr sz="919">
+                          <a:solidFill>
+                            <a:srgbClr val="172127"/>
+                          </a:solidFill>
+                          <a:latin typeface="Aptos"/>
+                        </a:defRPr>
+                      </a:pPr>
+                      <a:r>
+                        <a:t>0.843</a:t>
+                      </a:r>
+                    </a:p>
+                  </a:txBody>
+                  <a:tcPr marL="54864" marR="36576" marT="22860" marB="22860">
+                    <a:solidFill>
+                      <a:srgbClr val="E8F4EF"/>
+                    </a:solidFill>
+                  </a:tcPr>
+                </a:tc>
+              </a:tr>
+            </a:tbl>
+          </a:graphicData>
+        </a:graphic>
+      </p:graphicFrame>
+      <p:sp>
+        <p:nvSpPr>
+          <p:cNvPr id="11" name="Rectangle 10"/>
           <p:cNvSpPr/>
           <p:nvPr/>
         </p:nvSpPr>
         <p:spPr>
           <a:xfrm>
-            <a:off x="7479792" y="1399032"/>
-            <a:ext cx="4197096" cy="1078992"/>
+            <a:off x="6336792" y="4251960"/>
+            <a:ext cx="5340096" cy="1325880"/>
           </a:xfrm>
           <a:prstGeom prst="rect">
             <a:avLst/>
@@ -8030,14 +8708,14 @@
       </p:sp>
       <p:sp>
         <p:nvSpPr>
-          <p:cNvPr id="10" name="Rectangle 9"/>
+          <p:cNvPr id="12" name="Rectangle 11"/>
           <p:cNvSpPr/>
           <p:nvPr/>
         </p:nvSpPr>
         <p:spPr>
           <a:xfrm>
-            <a:off x="7479792" y="1399032"/>
-            <a:ext cx="54864" cy="1078992"/>
+            <a:off x="6336792" y="4251960"/>
+            <a:ext cx="54864" cy="1325880"/>
           </a:xfrm>
           <a:prstGeom prst="rect">
             <a:avLst/>
@@ -8075,14 +8753,14 @@
       </p:sp>
       <p:sp>
         <p:nvSpPr>
-          <p:cNvPr id="11" name="Text: 5 components passed"/>
+          <p:cNvPr id="13" name="Text: Adaptive risk stack: 15 / 15"/>
           <p:cNvSpPr txBox="1"/>
           <p:nvPr/>
         </p:nvSpPr>
         <p:spPr>
           <a:xfrm>
-            <a:off x="7680960" y="1545336"/>
-            <a:ext cx="3867911" cy="310896"/>
+            <a:off x="6537959" y="4398264"/>
+            <a:ext cx="5010912" cy="310896"/>
           </a:xfrm>
           <a:prstGeom prst="rect">
             <a:avLst/>
@@ -8107,21 +8785,21 @@
                 </a:solidFill>
                 <a:latin typeface="Aptos Display"/>
               </a:rPr>
-              <a:t>5 components passed</a:t>
-            </a:r>
-          </a:p>
-        </p:txBody>
-      </p:sp>
-      <p:sp>
-        <p:nvSpPr>
-          <p:cNvPr id="12" name="Text: Data integrity, forecasts, distributions, constrai"/>
+              <a:t>Adaptive risk stack: 15 / 15</a:t>
+            </a:r>
+          </a:p>
+        </p:txBody>
+      </p:sp>
+      <p:sp>
+        <p:nvSpPr>
+          <p:cNvPr id="14" name="Text: DCC-IGARCH Student-t, filtered historical simulati"/>
           <p:cNvSpPr txBox="1"/>
           <p:nvPr/>
         </p:nvSpPr>
         <p:spPr>
           <a:xfrm>
-            <a:off x="7680960" y="1920240"/>
-            <a:ext cx="3867911" cy="438912"/>
+            <a:off x="6537959" y="4773168"/>
+            <a:ext cx="5010912" cy="685800"/>
           </a:xfrm>
           <a:prstGeom prst="rect">
             <a:avLst/>
@@ -8146,350 +8824,14 @@
                 </a:solidFill>
                 <a:latin typeface="Aptos"/>
               </a:rPr>
-              <a:t>Data integrity, forecasts, distributions, constraints and stability met their configured gates.</a:t>
-            </a:r>
-          </a:p>
-        </p:txBody>
-      </p:sp>
-      <p:sp>
-        <p:nvSpPr>
-          <p:cNvPr id="13" name="Rectangle 12"/>
-          <p:cNvSpPr/>
-          <p:nvPr/>
-        </p:nvSpPr>
-        <p:spPr>
-          <a:xfrm>
-            <a:off x="7479792" y="2798064"/>
-            <a:ext cx="4197096" cy="1078992"/>
-          </a:xfrm>
-          <a:prstGeom prst="rect">
-            <a:avLst/>
-          </a:prstGeom>
-          <a:solidFill>
-            <a:srgbClr val="FBF3DF"/>
-          </a:solidFill>
-          <a:ln w="10160">
-            <a:solidFill>
-              <a:srgbClr val="FBF3DF"/>
-            </a:solidFill>
-          </a:ln>
-        </p:spPr>
-        <p:style>
-          <a:lnRef idx="1">
-            <a:schemeClr val="accent1"/>
-          </a:lnRef>
-          <a:fillRef idx="3">
-            <a:schemeClr val="accent1"/>
-          </a:fillRef>
-          <a:effectRef idx="2">
-            <a:schemeClr val="accent1"/>
-          </a:effectRef>
-          <a:fontRef idx="minor">
-            <a:schemeClr val="lt1"/>
-          </a:fontRef>
-        </p:style>
-        <p:txBody>
-          <a:bodyPr rtlCol="0" anchor="ctr"/>
-          <a:lstStyle/>
-          <a:p>
-            <a:pPr algn="ctr"/>
-          </a:p>
-        </p:txBody>
-      </p:sp>
-      <p:sp>
-        <p:nvSpPr>
-          <p:cNvPr id="14" name="Rectangle 13"/>
-          <p:cNvSpPr/>
-          <p:nvPr/>
-        </p:nvSpPr>
-        <p:spPr>
-          <a:xfrm>
-            <a:off x="7479792" y="2798064"/>
-            <a:ext cx="54864" cy="1078992"/>
-          </a:xfrm>
-          <a:prstGeom prst="rect">
-            <a:avLst/>
-          </a:prstGeom>
-          <a:solidFill>
-            <a:srgbClr val="C99328"/>
-          </a:solidFill>
-          <a:ln w="10160">
-            <a:solidFill>
-              <a:srgbClr val="C99328"/>
-            </a:solidFill>
-          </a:ln>
-        </p:spPr>
-        <p:style>
-          <a:lnRef idx="1">
-            <a:schemeClr val="accent1"/>
-          </a:lnRef>
-          <a:fillRef idx="3">
-            <a:schemeClr val="accent1"/>
-          </a:fillRef>
-          <a:effectRef idx="2">
-            <a:schemeClr val="accent1"/>
-          </a:effectRef>
-          <a:fontRef idx="minor">
-            <a:schemeClr val="lt1"/>
-          </a:fontRef>
-        </p:style>
-        <p:txBody>
-          <a:bodyPr rtlCol="0" anchor="ctr"/>
-          <a:lstStyle/>
-          <a:p>
-            <a:pPr algn="ctr"/>
-          </a:p>
-        </p:txBody>
-      </p:sp>
-      <p:sp>
-        <p:nvSpPr>
-          <p:cNvPr id="15" name="Text: 3 components warned"/>
-          <p:cNvSpPr txBox="1"/>
-          <p:nvPr/>
-        </p:nvSpPr>
-        <p:spPr>
-          <a:xfrm>
-            <a:off x="7680960" y="2944368"/>
-            <a:ext cx="3867911" cy="310896"/>
-          </a:xfrm>
-          <a:prstGeom prst="rect">
-            <a:avLst/>
-          </a:prstGeom>
-          <a:noFill/>
-        </p:spPr>
-        <p:txBody>
-          <a:bodyPr wrap="square" anchor="t" lIns="18288" rIns="18288" tIns="18288" bIns="18288">
-            <a:spAutoFit/>
-          </a:bodyPr>
-          <a:lstStyle/>
-          <a:p>
-            <a:pPr algn="l">
-              <a:spcAft>
-                <a:spcPts val="0"/>
-              </a:spcAft>
-            </a:pPr>
-            <a:r>
-              <a:rPr sz="1700" b="1">
-                <a:solidFill>
-                  <a:srgbClr val="172127"/>
-                </a:solidFill>
-                <a:latin typeface="Aptos Display"/>
-              </a:rPr>
-              <a:t>3 components warned</a:t>
-            </a:r>
-          </a:p>
-        </p:txBody>
-      </p:sp>
-      <p:sp>
-        <p:nvSpPr>
-          <p:cNvPr id="16" name="Text: Point-in-time evidence is reconstructed; risk exce"/>
-          <p:cNvSpPr txBox="1"/>
-          <p:nvPr/>
-        </p:nvSpPr>
-        <p:spPr>
-          <a:xfrm>
-            <a:off x="7680960" y="3319272"/>
-            <a:ext cx="3867911" cy="438912"/>
-          </a:xfrm>
-          <a:prstGeom prst="rect">
-            <a:avLst/>
-          </a:prstGeom>
-          <a:noFill/>
-        </p:spPr>
-        <p:txBody>
-          <a:bodyPr wrap="square" anchor="t" lIns="18288" rIns="18288" tIns="18288" bIns="18288">
-            <a:spAutoFit/>
-          </a:bodyPr>
-          <a:lstStyle/>
-          <a:p>
-            <a:pPr algn="l">
-              <a:spcAft>
-                <a:spcPts val="0"/>
-              </a:spcAft>
-            </a:pPr>
-            <a:r>
-              <a:rPr sz="1150" b="0">
-                <a:solidFill>
-                  <a:srgbClr val="647078"/>
-                </a:solidFill>
-                <a:latin typeface="Aptos"/>
-              </a:rPr>
-              <a:t>Point-in-time evidence is reconstructed; risk exceptions cluster; and costs consume too much return.</a:t>
-            </a:r>
-          </a:p>
-        </p:txBody>
-      </p:sp>
-      <p:sp>
-        <p:nvSpPr>
-          <p:cNvPr id="17" name="Rectangle 16"/>
-          <p:cNvSpPr/>
-          <p:nvPr/>
-        </p:nvSpPr>
-        <p:spPr>
-          <a:xfrm>
-            <a:off x="7479792" y="4197096"/>
-            <a:ext cx="4197096" cy="1078992"/>
-          </a:xfrm>
-          <a:prstGeom prst="rect">
-            <a:avLst/>
-          </a:prstGeom>
-          <a:solidFill>
-            <a:srgbClr val="E9F1F6"/>
-          </a:solidFill>
-          <a:ln w="10160">
-            <a:solidFill>
-              <a:srgbClr val="E9F1F6"/>
-            </a:solidFill>
-          </a:ln>
-        </p:spPr>
-        <p:style>
-          <a:lnRef idx="1">
-            <a:schemeClr val="accent1"/>
-          </a:lnRef>
-          <a:fillRef idx="3">
-            <a:schemeClr val="accent1"/>
-          </a:fillRef>
-          <a:effectRef idx="2">
-            <a:schemeClr val="accent1"/>
-          </a:effectRef>
-          <a:fontRef idx="minor">
-            <a:schemeClr val="lt1"/>
-          </a:fontRef>
-        </p:style>
-        <p:txBody>
-          <a:bodyPr rtlCol="0" anchor="ctr"/>
-          <a:lstStyle/>
-          <a:p>
-            <a:pPr algn="ctr"/>
-          </a:p>
-        </p:txBody>
-      </p:sp>
-      <p:sp>
-        <p:nvSpPr>
-          <p:cNvPr id="18" name="Rectangle 17"/>
-          <p:cNvSpPr/>
-          <p:nvPr/>
-        </p:nvSpPr>
-        <p:spPr>
-          <a:xfrm>
-            <a:off x="7479792" y="4197096"/>
-            <a:ext cx="54864" cy="1078992"/>
-          </a:xfrm>
-          <a:prstGeom prst="rect">
-            <a:avLst/>
-          </a:prstGeom>
-          <a:solidFill>
-            <a:srgbClr val="3478A5"/>
-          </a:solidFill>
-          <a:ln w="10160">
-            <a:solidFill>
-              <a:srgbClr val="3478A5"/>
-            </a:solidFill>
-          </a:ln>
-        </p:spPr>
-        <p:style>
-          <a:lnRef idx="1">
-            <a:schemeClr val="accent1"/>
-          </a:lnRef>
-          <a:fillRef idx="3">
-            <a:schemeClr val="accent1"/>
-          </a:fillRef>
-          <a:effectRef idx="2">
-            <a:schemeClr val="accent1"/>
-          </a:effectRef>
-          <a:fontRef idx="minor">
-            <a:schemeClr val="lt1"/>
-          </a:fontRef>
-        </p:style>
-        <p:txBody>
-          <a:bodyPr rtlCol="0" anchor="ctr"/>
-          <a:lstStyle/>
-          <a:p>
-            <a:pPr algn="ctr"/>
-          </a:p>
-        </p:txBody>
-      </p:sp>
-      <p:sp>
-        <p:nvSpPr>
-          <p:cNvPr id="19" name="Text: 0 critical failures"/>
-          <p:cNvSpPr txBox="1"/>
-          <p:nvPr/>
-        </p:nvSpPr>
-        <p:spPr>
-          <a:xfrm>
-            <a:off x="7680960" y="4343400"/>
-            <a:ext cx="3867911" cy="310896"/>
-          </a:xfrm>
-          <a:prstGeom prst="rect">
-            <a:avLst/>
-          </a:prstGeom>
-          <a:noFill/>
-        </p:spPr>
-        <p:txBody>
-          <a:bodyPr wrap="square" anchor="t" lIns="18288" rIns="18288" tIns="18288" bIns="18288">
-            <a:spAutoFit/>
-          </a:bodyPr>
-          <a:lstStyle/>
-          <a:p>
-            <a:pPr algn="l">
-              <a:spcAft>
-                <a:spcPts val="0"/>
-              </a:spcAft>
-            </a:pPr>
-            <a:r>
-              <a:rPr sz="1700" b="1">
-                <a:solidFill>
-                  <a:srgbClr val="172127"/>
-                </a:solidFill>
-                <a:latin typeface="Aptos Display"/>
-              </a:rPr>
-              <a:t>0 critical failures</a:t>
-            </a:r>
-          </a:p>
-        </p:txBody>
-      </p:sp>
-      <p:sp>
-        <p:nvSpPr>
-          <p:cNvPr id="20" name="Text: No leakage or hard-constraint failure was found. T"/>
-          <p:cNvSpPr txBox="1"/>
-          <p:nvPr/>
-        </p:nvSpPr>
-        <p:spPr>
-          <a:xfrm>
-            <a:off x="7680960" y="4718304"/>
-            <a:ext cx="3867911" cy="438912"/>
-          </a:xfrm>
-          <a:prstGeom prst="rect">
-            <a:avLst/>
-          </a:prstGeom>
-          <a:noFill/>
-        </p:spPr>
-        <p:txBody>
-          <a:bodyPr wrap="square" anchor="t" lIns="18288" rIns="18288" tIns="18288" bIns="18288">
-            <a:spAutoFit/>
-          </a:bodyPr>
-          <a:lstStyle/>
-          <a:p>
-            <a:pPr algn="l">
-              <a:spcAft>
-                <a:spcPts val="0"/>
-              </a:spcAft>
-            </a:pPr>
-            <a:r>
-              <a:rPr sz="1150" b="0">
-                <a:solidFill>
-                  <a:srgbClr val="647078"/>
-                </a:solidFill>
-                <a:latin typeface="Aptos"/>
-              </a:rPr>
-              <a:t>No leakage or hard-constraint failure was found. The warning status limits use but does not invalidate the entire model.</a:t>
-            </a:r>
-          </a:p>
-        </p:txBody>
-      </p:sp>
-      <p:sp>
-        <p:nvSpPr>
-          <p:cNvPr id="21" name="Text: Overall score 80/100  |  Conditional approval  |  "/>
+              <a:t>DCC-IGARCH Student-t, filtered historical simulation, EWMA Normal and EWMA Student-t are selected using trailing data. The holdout is chronological reconstructed evidence, not a pristine future shadow period.</a:t>
+            </a:r>
+          </a:p>
+        </p:txBody>
+      </p:sp>
+      <p:sp>
+        <p:nvSpPr>
+          <p:cNvPr id="15" name="Text: Overall 87.5/100  |  6 pass  |  PIT and portfolio "/>
           <p:cNvSpPr txBox="1"/>
           <p:nvPr/>
         </p:nvSpPr>
@@ -8515,13 +8857,13 @@
               </a:spcAft>
             </a:pPr>
             <a:r>
-              <a:rPr sz="1300" b="1">
+              <a:rPr sz="1230" b="1">
                 <a:solidFill>
                   <a:srgbClr val="0B6F56"/>
                 </a:solidFill>
                 <a:latin typeface="Aptos"/>
               </a:rPr>
-              <a:t>Overall score 80/100  |  Conditional approval  |  Human supervision required</a:t>
+              <a:t>Overall 87.5/100  |  6 pass  |  PIT and portfolio warnings  |  0 critical failures  |  full local suite passed</a:t>
             </a:r>
           </a:p>
         </p:txBody>
@@ -8554,7 +8896,7 @@
       <p:grpSpPr/>
       <p:sp>
         <p:nvSpPr>
-          <p:cNvPr id="2" name="Text: Costs are the clearest improvement opportunity"/>
+          <p:cNvPr id="2" name="Text: Turnover and modeled cost drag now meet target"/>
           <p:cNvSpPr txBox="1"/>
           <p:nvPr/>
         </p:nvSpPr>
@@ -8586,14 +8928,14 @@
                 </a:solidFill>
                 <a:latin typeface="Aptos Display"/>
               </a:rPr>
-              <a:t>Costs are the clearest improvement opportunity</a:t>
-            </a:r>
-          </a:p>
-        </p:txBody>
-      </p:sp>
-      <p:sp>
-        <p:nvSpPr>
-          <p:cNvPr id="3" name="Text: The model has enough gross return; implementation "/>
+              <a:t>Turnover and modeled cost drag now meet target</a:t>
+            </a:r>
+          </a:p>
+        </p:txBody>
+      </p:sp>
+      <p:sp>
+        <p:nvSpPr>
+          <p:cNvPr id="3" name="Text: Retention hysteresis and minimum-turnover transiti"/>
           <p:cNvSpPr txBox="1"/>
           <p:nvPr/>
         </p:nvSpPr>
@@ -8625,7 +8967,7 @@
                 </a:solidFill>
                 <a:latin typeface="Aptos"/>
               </a:rPr>
-              <a:t>The model has enough gross return; implementation is consuming too much of it.</a:t>
+              <a:t>Retention hysteresis and minimum-turnover transitions reduced churn.</a:t>
             </a:r>
           </a:p>
         </p:txBody>
@@ -8755,7 +9097,7 @@
       </p:sp>
       <p:sp>
         <p:nvSpPr>
-          <p:cNvPr id="7" name="Text: Point-in-time cost validation, turnover and DRL ac"/>
+          <p:cNvPr id="7" name="Text: Before/after point-in-time cost and turnover valid"/>
           <p:cNvSpPr txBox="1"/>
           <p:nvPr/>
         </p:nvSpPr>
@@ -8787,7 +9129,7 @@
                 </a:solidFill>
                 <a:latin typeface="Aptos"/>
               </a:rPr>
-              <a:t>Point-in-time cost validation, turnover and DRL acceptance</a:t>
+              <a:t>Before/after point-in-time cost and turnover validation</a:t>
             </a:r>
           </a:p>
         </p:txBody>
@@ -8808,8 +9150,8 @@
         </p:blipFill>
         <p:spPr>
           <a:xfrm>
-            <a:off x="438912" y="1631175"/>
-            <a:ext cx="6912864" cy="3787673"/>
+            <a:off x="438912" y="1606104"/>
+            <a:ext cx="6912864" cy="3837814"/>
           </a:xfrm>
           <a:prstGeom prst="rect">
             <a:avLst/>
@@ -8831,7 +9173,7 @@
             <a:avLst/>
           </a:prstGeom>
           <a:solidFill>
-            <a:srgbClr val="F8EAEA"/>
+            <a:srgbClr val="E8F4EF"/>
           </a:solidFill>
           <a:ln w="10160">
             <a:solidFill>
@@ -8876,11 +9218,11 @@
             <a:avLst/>
           </a:prstGeom>
           <a:solidFill>
-            <a:srgbClr val="BB4A4A"/>
+            <a:srgbClr val="14966F"/>
           </a:solidFill>
           <a:ln w="10160">
             <a:solidFill>
-              <a:srgbClr val="BB4A4A"/>
+              <a:srgbClr val="14966F"/>
             </a:solidFill>
           </a:ln>
         </p:spPr>
@@ -8908,7 +9250,7 @@
       </p:sp>
       <p:sp>
         <p:nvSpPr>
-          <p:cNvPr id="11" name="Text: 2.35%"/>
+          <p:cNvPr id="11" name="Text: 1.28%"/>
           <p:cNvSpPr txBox="1"/>
           <p:nvPr/>
         </p:nvSpPr>
@@ -8940,14 +9282,14 @@
                 </a:solidFill>
                 <a:latin typeface="Aptos Display"/>
               </a:rPr>
-              <a:t>2.35%</a:t>
-            </a:r>
-          </a:p>
-        </p:txBody>
-      </p:sp>
-      <p:sp>
-        <p:nvSpPr>
-          <p:cNvPr id="12" name="Text: annualised model cost drag"/>
+              <a:t>1.28%</a:t>
+            </a:r>
+          </a:p>
+        </p:txBody>
+      </p:sp>
+      <p:sp>
+        <p:nvSpPr>
+          <p:cNvPr id="12" name="Text: modeled cost drag; target &lt;= 1.50%"/>
           <p:cNvSpPr txBox="1"/>
           <p:nvPr/>
         </p:nvSpPr>
@@ -8979,7 +9321,7 @@
                 </a:solidFill>
                 <a:latin typeface="Aptos"/>
               </a:rPr>
-              <a:t>annualised model cost drag</a:t>
+              <a:t>modeled cost drag; target &lt;= 1.50%</a:t>
             </a:r>
           </a:p>
         </p:txBody>
@@ -8999,7 +9341,7 @@
             <a:avLst/>
           </a:prstGeom>
           <a:solidFill>
-            <a:srgbClr val="FBF3DF"/>
+            <a:srgbClr val="E8F4EF"/>
           </a:solidFill>
           <a:ln w="10160">
             <a:solidFill>
@@ -9039,6 +9381,342 @@
           <a:xfrm>
             <a:off x="7607808" y="2587752"/>
             <a:ext cx="50292" cy="932688"/>
+          </a:xfrm>
+          <a:prstGeom prst="rect">
+            <a:avLst/>
+          </a:prstGeom>
+          <a:solidFill>
+            <a:srgbClr val="14966F"/>
+          </a:solidFill>
+          <a:ln w="10160">
+            <a:solidFill>
+              <a:srgbClr val="14966F"/>
+            </a:solidFill>
+          </a:ln>
+        </p:spPr>
+        <p:style>
+          <a:lnRef idx="1">
+            <a:schemeClr val="accent1"/>
+          </a:lnRef>
+          <a:fillRef idx="3">
+            <a:schemeClr val="accent1"/>
+          </a:fillRef>
+          <a:effectRef idx="2">
+            <a:schemeClr val="accent1"/>
+          </a:effectRef>
+          <a:fontRef idx="minor">
+            <a:schemeClr val="lt1"/>
+          </a:fontRef>
+        </p:style>
+        <p:txBody>
+          <a:bodyPr rtlCol="0" anchor="ctr"/>
+          <a:lstStyle/>
+          <a:p>
+            <a:pPr algn="ctr"/>
+          </a:p>
+        </p:txBody>
+      </p:sp>
+      <p:sp>
+        <p:nvSpPr>
+          <p:cNvPr id="15" name="Text: 1.33x"/>
+          <p:cNvSpPr txBox="1"/>
+          <p:nvPr/>
+        </p:nvSpPr>
+        <p:spPr>
+          <a:xfrm>
+            <a:off x="7772400" y="2715768"/>
+            <a:ext cx="3813048" cy="310896"/>
+          </a:xfrm>
+          <a:prstGeom prst="rect">
+            <a:avLst/>
+          </a:prstGeom>
+          <a:noFill/>
+        </p:spPr>
+        <p:txBody>
+          <a:bodyPr wrap="square" anchor="t" lIns="18288" rIns="18288" tIns="18288" bIns="18288">
+            <a:spAutoFit/>
+          </a:bodyPr>
+          <a:lstStyle/>
+          <a:p>
+            <a:pPr algn="l">
+              <a:spcAft>
+                <a:spcPts val="0"/>
+              </a:spcAft>
+            </a:pPr>
+            <a:r>
+              <a:rPr sz="2100" b="1">
+                <a:solidFill>
+                  <a:srgbClr val="172127"/>
+                </a:solidFill>
+                <a:latin typeface="Aptos Display"/>
+              </a:rPr>
+              <a:t>1.33x</a:t>
+            </a:r>
+          </a:p>
+        </p:txBody>
+      </p:sp>
+      <p:sp>
+        <p:nvSpPr>
+          <p:cNvPr id="16" name="Text: annual turnover; target &lt;= 1.50x"/>
+          <p:cNvSpPr txBox="1"/>
+          <p:nvPr/>
+        </p:nvSpPr>
+        <p:spPr>
+          <a:xfrm>
+            <a:off x="7772400" y="3118104"/>
+            <a:ext cx="3813048" cy="201168"/>
+          </a:xfrm>
+          <a:prstGeom prst="rect">
+            <a:avLst/>
+          </a:prstGeom>
+          <a:noFill/>
+        </p:spPr>
+        <p:txBody>
+          <a:bodyPr wrap="square" anchor="t" lIns="18288" rIns="18288" tIns="18288" bIns="18288">
+            <a:spAutoFit/>
+          </a:bodyPr>
+          <a:lstStyle/>
+          <a:p>
+            <a:pPr algn="l">
+              <a:spcAft>
+                <a:spcPts val="0"/>
+              </a:spcAft>
+            </a:pPr>
+            <a:r>
+              <a:rPr sz="950" b="0">
+                <a:solidFill>
+                  <a:srgbClr val="647078"/>
+                </a:solidFill>
+                <a:latin typeface="Aptos"/>
+              </a:rPr>
+              <a:t>annual turnover; target &lt;= 1.50x</a:t>
+            </a:r>
+          </a:p>
+        </p:txBody>
+      </p:sp>
+      <p:sp>
+        <p:nvSpPr>
+          <p:cNvPr id="17" name="Rectangle 16"/>
+          <p:cNvSpPr/>
+          <p:nvPr/>
+        </p:nvSpPr>
+        <p:spPr>
+          <a:xfrm>
+            <a:off x="7607808" y="3739896"/>
+            <a:ext cx="4069080" cy="932688"/>
+          </a:xfrm>
+          <a:prstGeom prst="rect">
+            <a:avLst/>
+          </a:prstGeom>
+          <a:solidFill>
+            <a:srgbClr val="FFFFFF"/>
+          </a:solidFill>
+          <a:ln w="10160">
+            <a:solidFill>
+              <a:srgbClr val="D8E0DD"/>
+            </a:solidFill>
+          </a:ln>
+        </p:spPr>
+        <p:style>
+          <a:lnRef idx="1">
+            <a:schemeClr val="accent1"/>
+          </a:lnRef>
+          <a:fillRef idx="3">
+            <a:schemeClr val="accent1"/>
+          </a:fillRef>
+          <a:effectRef idx="2">
+            <a:schemeClr val="accent1"/>
+          </a:effectRef>
+          <a:fontRef idx="minor">
+            <a:schemeClr val="lt1"/>
+          </a:fontRef>
+        </p:style>
+        <p:txBody>
+          <a:bodyPr rtlCol="0" anchor="ctr"/>
+          <a:lstStyle/>
+          <a:p>
+            <a:pPr algn="ctr"/>
+          </a:p>
+        </p:txBody>
+      </p:sp>
+      <p:sp>
+        <p:nvSpPr>
+          <p:cNvPr id="18" name="Rectangle 17"/>
+          <p:cNvSpPr/>
+          <p:nvPr/>
+        </p:nvSpPr>
+        <p:spPr>
+          <a:xfrm>
+            <a:off x="7607808" y="3739896"/>
+            <a:ext cx="50292" cy="932688"/>
+          </a:xfrm>
+          <a:prstGeom prst="rect">
+            <a:avLst/>
+          </a:prstGeom>
+          <a:solidFill>
+            <a:srgbClr val="3478A5"/>
+          </a:solidFill>
+          <a:ln w="10160">
+            <a:solidFill>
+              <a:srgbClr val="3478A5"/>
+            </a:solidFill>
+          </a:ln>
+        </p:spPr>
+        <p:style>
+          <a:lnRef idx="1">
+            <a:schemeClr val="accent1"/>
+          </a:lnRef>
+          <a:fillRef idx="3">
+            <a:schemeClr val="accent1"/>
+          </a:fillRef>
+          <a:effectRef idx="2">
+            <a:schemeClr val="accent1"/>
+          </a:effectRef>
+          <a:fontRef idx="minor">
+            <a:schemeClr val="lt1"/>
+          </a:fontRef>
+        </p:style>
+        <p:txBody>
+          <a:bodyPr rtlCol="0" anchor="ctr"/>
+          <a:lstStyle/>
+          <a:p>
+            <a:pPr algn="ctr"/>
+          </a:p>
+        </p:txBody>
+      </p:sp>
+      <p:sp>
+        <p:nvSpPr>
+          <p:cNvPr id="19" name="Text: $465k"/>
+          <p:cNvSpPr txBox="1"/>
+          <p:nvPr/>
+        </p:nvSpPr>
+        <p:spPr>
+          <a:xfrm>
+            <a:off x="7772400" y="3867911"/>
+            <a:ext cx="3813048" cy="310896"/>
+          </a:xfrm>
+          <a:prstGeom prst="rect">
+            <a:avLst/>
+          </a:prstGeom>
+          <a:noFill/>
+        </p:spPr>
+        <p:txBody>
+          <a:bodyPr wrap="square" anchor="t" lIns="18288" rIns="18288" tIns="18288" bIns="18288">
+            <a:spAutoFit/>
+          </a:bodyPr>
+          <a:lstStyle/>
+          <a:p>
+            <a:pPr algn="l">
+              <a:spcAft>
+                <a:spcPts val="0"/>
+              </a:spcAft>
+            </a:pPr>
+            <a:r>
+              <a:rPr sz="2100" b="1">
+                <a:solidFill>
+                  <a:srgbClr val="172127"/>
+                </a:solidFill>
+                <a:latin typeface="Aptos Display"/>
+              </a:rPr>
+              <a:t>$465k</a:t>
+            </a:r>
+          </a:p>
+        </p:txBody>
+      </p:sp>
+      <p:sp>
+        <p:nvSpPr>
+          <p:cNvPr id="20" name="Text: 0.25% annual bank fee at reference AUM"/>
+          <p:cNvSpPr txBox="1"/>
+          <p:nvPr/>
+        </p:nvSpPr>
+        <p:spPr>
+          <a:xfrm>
+            <a:off x="7772400" y="4270248"/>
+            <a:ext cx="3813048" cy="201168"/>
+          </a:xfrm>
+          <a:prstGeom prst="rect">
+            <a:avLst/>
+          </a:prstGeom>
+          <a:noFill/>
+        </p:spPr>
+        <p:txBody>
+          <a:bodyPr wrap="square" anchor="t" lIns="18288" rIns="18288" tIns="18288" bIns="18288">
+            <a:spAutoFit/>
+          </a:bodyPr>
+          <a:lstStyle/>
+          <a:p>
+            <a:pPr algn="l">
+              <a:spcAft>
+                <a:spcPts val="0"/>
+              </a:spcAft>
+            </a:pPr>
+            <a:r>
+              <a:rPr sz="950" b="0">
+                <a:solidFill>
+                  <a:srgbClr val="647078"/>
+                </a:solidFill>
+                <a:latin typeface="Aptos"/>
+              </a:rPr>
+              <a:t>0.25% annual bank fee at reference AUM</a:t>
+            </a:r>
+          </a:p>
+        </p:txBody>
+      </p:sp>
+      <p:sp>
+        <p:nvSpPr>
+          <p:cNvPr id="21" name="Rectangle 20"/>
+          <p:cNvSpPr/>
+          <p:nvPr/>
+        </p:nvSpPr>
+        <p:spPr>
+          <a:xfrm>
+            <a:off x="7607808" y="4892040"/>
+            <a:ext cx="4069080" cy="941832"/>
+          </a:xfrm>
+          <a:prstGeom prst="rect">
+            <a:avLst/>
+          </a:prstGeom>
+          <a:solidFill>
+            <a:srgbClr val="FBF3DF"/>
+          </a:solidFill>
+          <a:ln w="10160">
+            <a:solidFill>
+              <a:srgbClr val="FBF3DF"/>
+            </a:solidFill>
+          </a:ln>
+        </p:spPr>
+        <p:style>
+          <a:lnRef idx="1">
+            <a:schemeClr val="accent1"/>
+          </a:lnRef>
+          <a:fillRef idx="3">
+            <a:schemeClr val="accent1"/>
+          </a:fillRef>
+          <a:effectRef idx="2">
+            <a:schemeClr val="accent1"/>
+          </a:effectRef>
+          <a:fontRef idx="minor">
+            <a:schemeClr val="lt1"/>
+          </a:fontRef>
+        </p:style>
+        <p:txBody>
+          <a:bodyPr rtlCol="0" anchor="ctr"/>
+          <a:lstStyle/>
+          <a:p>
+            <a:pPr algn="ctr"/>
+          </a:p>
+        </p:txBody>
+      </p:sp>
+      <p:sp>
+        <p:nvSpPr>
+          <p:cNvPr id="22" name="Rectangle 21"/>
+          <p:cNvSpPr/>
+          <p:nvPr/>
+        </p:nvSpPr>
+        <p:spPr>
+          <a:xfrm>
+            <a:off x="7607808" y="4892040"/>
+            <a:ext cx="54864" cy="941832"/>
           </a:xfrm>
           <a:prstGeom prst="rect">
             <a:avLst/>
@@ -9076,343 +9754,7 @@
       </p:sp>
       <p:sp>
         <p:nvSpPr>
-          <p:cNvPr id="15" name="Text: 2.11x"/>
-          <p:cNvSpPr txBox="1"/>
-          <p:nvPr/>
-        </p:nvSpPr>
-        <p:spPr>
-          <a:xfrm>
-            <a:off x="7772400" y="2715768"/>
-            <a:ext cx="3813048" cy="310896"/>
-          </a:xfrm>
-          <a:prstGeom prst="rect">
-            <a:avLst/>
-          </a:prstGeom>
-          <a:noFill/>
-        </p:spPr>
-        <p:txBody>
-          <a:bodyPr wrap="square" anchor="t" lIns="18288" rIns="18288" tIns="18288" bIns="18288">
-            <a:spAutoFit/>
-          </a:bodyPr>
-          <a:lstStyle/>
-          <a:p>
-            <a:pPr algn="l">
-              <a:spcAft>
-                <a:spcPts val="0"/>
-              </a:spcAft>
-            </a:pPr>
-            <a:r>
-              <a:rPr sz="2100" b="1">
-                <a:solidFill>
-                  <a:srgbClr val="172127"/>
-                </a:solidFill>
-                <a:latin typeface="Aptos Display"/>
-              </a:rPr>
-              <a:t>2.11x</a:t>
-            </a:r>
-          </a:p>
-        </p:txBody>
-      </p:sp>
-      <p:sp>
-        <p:nvSpPr>
-          <p:cNvPr id="16" name="Text: annualised turnover"/>
-          <p:cNvSpPr txBox="1"/>
-          <p:nvPr/>
-        </p:nvSpPr>
-        <p:spPr>
-          <a:xfrm>
-            <a:off x="7772400" y="3118104"/>
-            <a:ext cx="3813048" cy="201168"/>
-          </a:xfrm>
-          <a:prstGeom prst="rect">
-            <a:avLst/>
-          </a:prstGeom>
-          <a:noFill/>
-        </p:spPr>
-        <p:txBody>
-          <a:bodyPr wrap="square" anchor="t" lIns="18288" rIns="18288" tIns="18288" bIns="18288">
-            <a:spAutoFit/>
-          </a:bodyPr>
-          <a:lstStyle/>
-          <a:p>
-            <a:pPr algn="l">
-              <a:spcAft>
-                <a:spcPts val="0"/>
-              </a:spcAft>
-            </a:pPr>
-            <a:r>
-              <a:rPr sz="950" b="0">
-                <a:solidFill>
-                  <a:srgbClr val="647078"/>
-                </a:solidFill>
-                <a:latin typeface="Aptos"/>
-              </a:rPr>
-              <a:t>annualised turnover</a:t>
-            </a:r>
-          </a:p>
-        </p:txBody>
-      </p:sp>
-      <p:sp>
-        <p:nvSpPr>
-          <p:cNvPr id="17" name="Rectangle 16"/>
-          <p:cNvSpPr/>
-          <p:nvPr/>
-        </p:nvSpPr>
-        <p:spPr>
-          <a:xfrm>
-            <a:off x="7607808" y="3739896"/>
-            <a:ext cx="4069080" cy="932688"/>
-          </a:xfrm>
-          <a:prstGeom prst="rect">
-            <a:avLst/>
-          </a:prstGeom>
-          <a:solidFill>
-            <a:srgbClr val="FFFFFF"/>
-          </a:solidFill>
-          <a:ln w="10160">
-            <a:solidFill>
-              <a:srgbClr val="D8E0DD"/>
-            </a:solidFill>
-          </a:ln>
-        </p:spPr>
-        <p:style>
-          <a:lnRef idx="1">
-            <a:schemeClr val="accent1"/>
-          </a:lnRef>
-          <a:fillRef idx="3">
-            <a:schemeClr val="accent1"/>
-          </a:fillRef>
-          <a:effectRef idx="2">
-            <a:schemeClr val="accent1"/>
-          </a:effectRef>
-          <a:fontRef idx="minor">
-            <a:schemeClr val="lt1"/>
-          </a:fontRef>
-        </p:style>
-        <p:txBody>
-          <a:bodyPr rtlCol="0" anchor="ctr"/>
-          <a:lstStyle/>
-          <a:p>
-            <a:pPr algn="ctr"/>
-          </a:p>
-        </p:txBody>
-      </p:sp>
-      <p:sp>
-        <p:nvSpPr>
-          <p:cNvPr id="18" name="Rectangle 17"/>
-          <p:cNvSpPr/>
-          <p:nvPr/>
-        </p:nvSpPr>
-        <p:spPr>
-          <a:xfrm>
-            <a:off x="7607808" y="3739896"/>
-            <a:ext cx="50292" cy="932688"/>
-          </a:xfrm>
-          <a:prstGeom prst="rect">
-            <a:avLst/>
-          </a:prstGeom>
-          <a:solidFill>
-            <a:srgbClr val="3478A5"/>
-          </a:solidFill>
-          <a:ln w="10160">
-            <a:solidFill>
-              <a:srgbClr val="3478A5"/>
-            </a:solidFill>
-          </a:ln>
-        </p:spPr>
-        <p:style>
-          <a:lnRef idx="1">
-            <a:schemeClr val="accent1"/>
-          </a:lnRef>
-          <a:fillRef idx="3">
-            <a:schemeClr val="accent1"/>
-          </a:fillRef>
-          <a:effectRef idx="2">
-            <a:schemeClr val="accent1"/>
-          </a:effectRef>
-          <a:fontRef idx="minor">
-            <a:schemeClr val="lt1"/>
-          </a:fontRef>
-        </p:style>
-        <p:txBody>
-          <a:bodyPr rtlCol="0" anchor="ctr"/>
-          <a:lstStyle/>
-          <a:p>
-            <a:pPr algn="ctr"/>
-          </a:p>
-        </p:txBody>
-      </p:sp>
-      <p:sp>
-        <p:nvSpPr>
-          <p:cNvPr id="19" name="Text: $465k"/>
-          <p:cNvSpPr txBox="1"/>
-          <p:nvPr/>
-        </p:nvSpPr>
-        <p:spPr>
-          <a:xfrm>
-            <a:off x="7772400" y="3867911"/>
-            <a:ext cx="3813048" cy="310896"/>
-          </a:xfrm>
-          <a:prstGeom prst="rect">
-            <a:avLst/>
-          </a:prstGeom>
-          <a:noFill/>
-        </p:spPr>
-        <p:txBody>
-          <a:bodyPr wrap="square" anchor="t" lIns="18288" rIns="18288" tIns="18288" bIns="18288">
-            <a:spAutoFit/>
-          </a:bodyPr>
-          <a:lstStyle/>
-          <a:p>
-            <a:pPr algn="l">
-              <a:spcAft>
-                <a:spcPts val="0"/>
-              </a:spcAft>
-            </a:pPr>
-            <a:r>
-              <a:rPr sz="2100" b="1">
-                <a:solidFill>
-                  <a:srgbClr val="172127"/>
-                </a:solidFill>
-                <a:latin typeface="Aptos Display"/>
-              </a:rPr>
-              <a:t>$465k</a:t>
-            </a:r>
-          </a:p>
-        </p:txBody>
-      </p:sp>
-      <p:sp>
-        <p:nvSpPr>
-          <p:cNvPr id="20" name="Text: first annual bank fee at reference AUM"/>
-          <p:cNvSpPr txBox="1"/>
-          <p:nvPr/>
-        </p:nvSpPr>
-        <p:spPr>
-          <a:xfrm>
-            <a:off x="7772400" y="4270248"/>
-            <a:ext cx="3813048" cy="201168"/>
-          </a:xfrm>
-          <a:prstGeom prst="rect">
-            <a:avLst/>
-          </a:prstGeom>
-          <a:noFill/>
-        </p:spPr>
-        <p:txBody>
-          <a:bodyPr wrap="square" anchor="t" lIns="18288" rIns="18288" tIns="18288" bIns="18288">
-            <a:spAutoFit/>
-          </a:bodyPr>
-          <a:lstStyle/>
-          <a:p>
-            <a:pPr algn="l">
-              <a:spcAft>
-                <a:spcPts val="0"/>
-              </a:spcAft>
-            </a:pPr>
-            <a:r>
-              <a:rPr sz="950" b="0">
-                <a:solidFill>
-                  <a:srgbClr val="647078"/>
-                </a:solidFill>
-                <a:latin typeface="Aptos"/>
-              </a:rPr>
-              <a:t>first annual bank fee at reference AUM</a:t>
-            </a:r>
-          </a:p>
-        </p:txBody>
-      </p:sp>
-      <p:sp>
-        <p:nvSpPr>
-          <p:cNvPr id="21" name="Rectangle 20"/>
-          <p:cNvSpPr/>
-          <p:nvPr/>
-        </p:nvSpPr>
-        <p:spPr>
-          <a:xfrm>
-            <a:off x="7607808" y="4892040"/>
-            <a:ext cx="4069080" cy="941832"/>
-          </a:xfrm>
-          <a:prstGeom prst="rect">
-            <a:avLst/>
-          </a:prstGeom>
-          <a:solidFill>
-            <a:srgbClr val="E9F1F6"/>
-          </a:solidFill>
-          <a:ln w="10160">
-            <a:solidFill>
-              <a:srgbClr val="E9F1F6"/>
-            </a:solidFill>
-          </a:ln>
-        </p:spPr>
-        <p:style>
-          <a:lnRef idx="1">
-            <a:schemeClr val="accent1"/>
-          </a:lnRef>
-          <a:fillRef idx="3">
-            <a:schemeClr val="accent1"/>
-          </a:fillRef>
-          <a:effectRef idx="2">
-            <a:schemeClr val="accent1"/>
-          </a:effectRef>
-          <a:fontRef idx="minor">
-            <a:schemeClr val="lt1"/>
-          </a:fontRef>
-        </p:style>
-        <p:txBody>
-          <a:bodyPr rtlCol="0" anchor="ctr"/>
-          <a:lstStyle/>
-          <a:p>
-            <a:pPr algn="ctr"/>
-          </a:p>
-        </p:txBody>
-      </p:sp>
-      <p:sp>
-        <p:nvSpPr>
-          <p:cNvPr id="22" name="Rectangle 21"/>
-          <p:cNvSpPr/>
-          <p:nvPr/>
-        </p:nvSpPr>
-        <p:spPr>
-          <a:xfrm>
-            <a:off x="7607808" y="4892040"/>
-            <a:ext cx="54864" cy="941832"/>
-          </a:xfrm>
-          <a:prstGeom prst="rect">
-            <a:avLst/>
-          </a:prstGeom>
-          <a:solidFill>
-            <a:srgbClr val="3478A5"/>
-          </a:solidFill>
-          <a:ln w="10160">
-            <a:solidFill>
-              <a:srgbClr val="3478A5"/>
-            </a:solidFill>
-          </a:ln>
-        </p:spPr>
-        <p:style>
-          <a:lnRef idx="1">
-            <a:schemeClr val="accent1"/>
-          </a:lnRef>
-          <a:fillRef idx="3">
-            <a:schemeClr val="accent1"/>
-          </a:fillRef>
-          <a:effectRef idx="2">
-            <a:schemeClr val="accent1"/>
-          </a:effectRef>
-          <a:fontRef idx="minor">
-            <a:schemeClr val="lt1"/>
-          </a:fontRef>
-        </p:style>
-        <p:txBody>
-          <a:bodyPr rtlCol="0" anchor="ctr"/>
-          <a:lstStyle/>
-          <a:p>
-            <a:pPr algn="ctr"/>
-          </a:p>
-        </p:txBody>
-      </p:sp>
-      <p:sp>
-        <p:nvSpPr>
-          <p:cNvPr id="23" name="Text: DRL stayed out"/>
+          <p:cNvPr id="23" name="Text: Why portfolio remains a warning"/>
           <p:cNvSpPr txBox="1"/>
           <p:nvPr/>
         </p:nvSpPr>
@@ -9444,14 +9786,14 @@
                 </a:solidFill>
                 <a:latin typeface="Aptos Display"/>
               </a:rPr>
-              <a:t>DRL stayed out</a:t>
-            </a:r>
-          </a:p>
-        </p:txBody>
-      </p:sp>
-      <p:sp>
-        <p:nvSpPr>
-          <p:cNvPr id="24" name="Text: The challenger breached its turnover hard limit, s"/>
+              <a:t>Why portfolio remains a warning</a:t>
+            </a:r>
+          </a:p>
+        </p:txBody>
+      </p:sp>
+      <p:sp>
+        <p:nvSpPr>
+          <p:cNvPr id="24" name="Text: Both cost gates pass, but Wolf trailed equal weigh"/>
           <p:cNvSpPr txBox="1"/>
           <p:nvPr/>
         </p:nvSpPr>
@@ -9483,14 +9825,14 @@
                 </a:solidFill>
                 <a:latin typeface="Aptos"/>
               </a:rPr>
-              <a:t>The challenger breached its turnover hard limit, so its weight was set to zero and the baseline optimiser remained final.</a:t>
-            </a:r>
-          </a:p>
-        </p:txBody>
-      </p:sp>
-      <p:sp>
-        <p:nvSpPr>
-          <p:cNvPr id="25" name="Text: Priority fixes: no-trade bands, staged transitions"/>
+              <a:t>Both cost gates pass, but Wolf trailed equal weight by 1.06% per year and the difference was not significant (p=0.734).</a:t>
+            </a:r>
+          </a:p>
+        </p:txBody>
+      </p:sp>
+      <p:sp>
+        <p:nvSpPr>
+          <p:cNvPr id="25" name="Text: Retention and capped/minimum-turnover transitions "/>
           <p:cNvSpPr txBox="1"/>
           <p:nvPr/>
         </p:nvSpPr>
@@ -9516,13 +9858,13 @@
               </a:spcAft>
             </a:pPr>
             <a:r>
-              <a:rPr sz="1250" b="1">
+              <a:rPr sz="1180" b="1">
                 <a:solidFill>
                   <a:srgbClr val="0B6F56"/>
                 </a:solidFill>
                 <a:latin typeface="Aptos"/>
               </a:rPr>
-              <a:t>Priority fixes: no-trade bands, staged transitions, turnover penalties and pre-trade cost quotes.</a:t>
+              <a:t>Retention and capped/minimum-turnover transitions drove the improvement; the configured no-trade band did not trigger in this sample.</a:t>
             </a:r>
           </a:p>
         </p:txBody>
@@ -10528,7 +10870,7 @@
               </a:defRPr>
             </a:pPr>
             <a:r>
-              <a:t>• Annualised turnover below 1.0x during the pilot</a:t>
+              <a:t>• Keep turnover &lt;=1.5x; stretch goal &lt;=1.0x in the pilot</a:t>
             </a:r>
           </a:p>
           <a:p>
@@ -10702,7 +11044,7 @@
       </p:sp>
       <p:sp>
         <p:nvSpPr>
-          <p:cNvPr id="28" name="Text: Stale critical data, any hard breach, unexplained "/>
+          <p:cNvPr id="28" name="Text: Stale critical data, any hard breach, a failed liv"/>
           <p:cNvSpPr txBox="1"/>
           <p:nvPr/>
         </p:nvSpPr>
@@ -10734,7 +11076,7 @@
                 </a:solidFill>
                 <a:latin typeface="Aptos"/>
               </a:rPr>
-              <a:t>Stale critical data, any hard breach, unexplained risk exception clustering, failed reconciliation or trading costs above the approved budget.</a:t>
+              <a:t>Stale critical data, any hard breach, a failed live risk test, failed reconciliation or trading costs above the approved budget.</a:t>
             </a:r>
           </a:p>
         </p:txBody>
@@ -12345,7 +12687,7 @@
       </p:sp>
       <p:sp>
         <p:nvSpPr>
-          <p:cNvPr id="7" name="Text: Ranking, diversification, risk and governance"/>
+          <p:cNvPr id="7" name="Text: Ranking, diversification, adaptive risk and govern"/>
           <p:cNvSpPr txBox="1"/>
           <p:nvPr/>
         </p:nvSpPr>
@@ -12377,7 +12719,7 @@
                 </a:solidFill>
                 <a:latin typeface="Aptos"/>
               </a:rPr>
-              <a:t>Ranking, diversification, risk and governance</a:t>
+              <a:t>Ranking, diversification, adaptive risk and governance</a:t>
             </a:r>
           </a:p>
         </p:txBody>
@@ -12468,7 +12810,7 @@
       </p:sp>
       <p:sp>
         <p:nvSpPr>
-          <p:cNvPr id="10" name="Text: Net benchmark edge and tail-risk independence"/>
+          <p:cNvPr id="10" name="Text: Net benchmark edge in a genuine future shadow reco"/>
           <p:cNvSpPr txBox="1"/>
           <p:nvPr/>
         </p:nvSpPr>
@@ -12500,7 +12842,7 @@
                 </a:solidFill>
                 <a:latin typeface="Aptos"/>
               </a:rPr>
-              <a:t>Net benchmark edge and tail-risk independence</a:t>
+              <a:t>Net benchmark edge in a genuine future shadow record</a:t>
             </a:r>
           </a:p>
         </p:txBody>
@@ -12591,7 +12933,7 @@
       </p:sp>
       <p:sp>
         <p:nvSpPr>
-          <p:cNvPr id="13" name="Text: Turnover, trading costs and data vintages"/>
+          <p:cNvPr id="13" name="Text: Observed PIT vintages and probability calibration"/>
           <p:cNvSpPr txBox="1"/>
           <p:nvPr/>
         </p:nvSpPr>
@@ -12623,7 +12965,7 @@
                 </a:solidFill>
                 <a:latin typeface="Aptos"/>
               </a:rPr>
-              <a:t>Turnover, trading costs and data vintages</a:t>
+              <a:t>Observed PIT vintages and probability calibration</a:t>
             </a:r>
           </a:p>
         </p:txBody>
@@ -12714,7 +13056,7 @@
       </p:sp>
       <p:sp>
         <p:nvSpPr>
-          <p:cNvPr id="16" name="Text: CONDITIONALLY_APPROVED  |  Governance 80/100  |  A"/>
+          <p:cNvPr id="16" name="Text: CONDITIONALLY_APPROVED  |  Governance 87.5/100  | "/>
           <p:cNvSpPr txBox="1"/>
           <p:nvPr/>
         </p:nvSpPr>
@@ -12746,7 +13088,7 @@
                 </a:solidFill>
                 <a:latin typeface="Aptos"/>
               </a:rPr>
-              <a:t>CONDITIONALLY_APPROVED  |  Governance 80/100  |  As of 12 August 2026</a:t>
+              <a:t>CONDITIONALLY_APPROVED  |  Governance 87.5/100  |  As of 13 August 2026</a:t>
             </a:r>
           </a:p>
         </p:txBody>
@@ -12818,7 +13160,7 @@
       </p:sp>
       <p:sp>
         <p:nvSpPr>
-          <p:cNvPr id="3" name="Text: Use the model as a governed process, not as an alp"/>
+          <p:cNvPr id="3" name="Text: The controls improved materially; the alpha claim "/>
           <p:cNvSpPr txBox="1"/>
           <p:nvPr/>
         </p:nvSpPr>
@@ -12850,7 +13192,7 @@
                 </a:solidFill>
                 <a:latin typeface="Aptos"/>
               </a:rPr>
-              <a:t>Use the model as a governed process, not as an alpha promise.</a:t>
+              <a:t>The controls improved materially; the alpha claim did not.</a:t>
             </a:r>
           </a:p>
         </p:txBody>
@@ -12980,7 +13322,7 @@
       </p:sp>
       <p:sp>
         <p:nvSpPr>
-          <p:cNvPr id="7" name="Text: Validation scorecard and point-in-time strategy co"/>
+          <p:cNvPr id="7" name="Text: 13 August validation scorecard and point-in-time c"/>
           <p:cNvSpPr txBox="1"/>
           <p:nvPr/>
         </p:nvSpPr>
@@ -13012,7 +13354,7 @@
                 </a:solidFill>
                 <a:latin typeface="Aptos"/>
               </a:rPr>
-              <a:t>Validation scorecard and point-in-time strategy comparison</a:t>
+              <a:t>13 August validation scorecard and point-in-time comparison</a:t>
             </a:r>
           </a:p>
         </p:txBody>
@@ -13280,7 +13622,7 @@
               </a:defRPr>
             </a:pPr>
             <a:r>
-              <a:t>• Five years of dated proxy decisions with positive net results</a:t>
+              <a:t>• Adaptive VaR passes overall and chronological holdout tests</a:t>
             </a:r>
           </a:p>
           <a:p>
@@ -13299,7 +13641,7 @@
               </a:defRPr>
             </a:pPr>
             <a:r>
-              <a:t>• Hard portfolio limits held in every validated decision</a:t>
+              <a:t>• Turnover and modeled cost drag now meet both 1.5 targets</a:t>
             </a:r>
           </a:p>
           <a:p>
@@ -13318,7 +13660,7 @@
               </a:defRPr>
             </a:pPr>
             <a:r>
-              <a:t>• Auditable inputs, forecasts, trades and governance outputs</a:t>
+              <a:t>• Zero hard breaches with auditable forecasts and trades</a:t>
             </a:r>
           </a:p>
         </p:txBody>
@@ -13454,7 +13796,7 @@
       </p:sp>
       <p:sp>
         <p:nvSpPr>
-          <p:cNvPr id="17" name="Text: Alpha is not statistically established. Turnover c"/>
+          <p:cNvPr id="17" name="Text: Observed PIT evidence is incomplete, and Wolf lagg"/>
           <p:cNvSpPr txBox="1"/>
           <p:nvPr/>
         </p:nvSpPr>
@@ -13486,7 +13828,7 @@
                 </a:solidFill>
                 <a:latin typeface="Aptos"/>
               </a:rPr>
-              <a:t>Alpha is not statistically established. Turnover consumes 2.35% per year, and tail-loss violations cluster over time.</a:t>
+              <a:t>Observed PIT evidence is incomplete, and Wolf lagged equal weight by 1.06% per year in this 60-month sample (p=0.734).</a:t>
             </a:r>
           </a:p>
         </p:txBody>
@@ -13677,7 +14019,7 @@
                         </a:defRPr>
                       </a:pPr>
                       <a:r>
-                        <a:t>Hard constraints</a:t>
+                        <a:t>Risk backtest</a:t>
                       </a:r>
                     </a:p>
                   </a:txBody>
@@ -13701,7 +14043,7 @@
                         </a:defRPr>
                       </a:pPr>
                       <a:r>
-                        <a:t>0 breaches</a:t>
+                        <a:t>15 / 15</a:t>
                       </a:r>
                     </a:p>
                   </a:txBody>
@@ -13725,7 +14067,7 @@
                         </a:defRPr>
                       </a:pPr>
                       <a:r>
-                        <a:t>Use</a:t>
+                        <a:t>Pass</a:t>
                       </a:r>
                     </a:p>
                   </a:txBody>
@@ -13751,7 +14093,7 @@
                         </a:defRPr>
                       </a:pPr>
                       <a:r>
-                        <a:t>Forecast calibration</a:t>
+                        <a:t>Cost controls</a:t>
                       </a:r>
                     </a:p>
                   </a:txBody>
@@ -13775,7 +14117,7 @@
                         </a:defRPr>
                       </a:pPr>
                       <a:r>
-                        <a:t>Pass</a:t>
+                        <a:t>Both targets met</a:t>
                       </a:r>
                     </a:p>
                   </a:txBody>
@@ -13799,7 +14141,7 @@
                         </a:defRPr>
                       </a:pPr>
                       <a:r>
-                        <a:t>Use</a:t>
+                        <a:t>Pass</a:t>
                       </a:r>
                     </a:p>
                   </a:txBody>
@@ -13825,13 +14167,13 @@
                         </a:defRPr>
                       </a:pPr>
                       <a:r>
-                        <a:t>Risk backtest</a:t>
-                      </a:r>
-                    </a:p>
-                  </a:txBody>
-                  <a:tcPr marL="54864" marR="36576" marT="22860" marB="22860">
-                    <a:solidFill>
-                      <a:srgbClr val="FFFFFF"/>
+                        <a:t>Hard constraints</a:t>
+                      </a:r>
+                    </a:p>
+                  </a:txBody>
+                  <a:tcPr marL="54864" marR="36576" marT="22860" marB="22860">
+                    <a:solidFill>
+                      <a:srgbClr val="E8F4EF"/>
                     </a:solidFill>
                   </a:tcPr>
                 </a:tc>
@@ -13849,13 +14191,13 @@
                         </a:defRPr>
                       </a:pPr>
                       <a:r>
-                        <a:t>Warning</a:t>
-                      </a:r>
-                    </a:p>
-                  </a:txBody>
-                  <a:tcPr marL="54864" marR="36576" marT="22860" marB="22860">
-                    <a:solidFill>
-                      <a:srgbClr val="FFFFFF"/>
+                        <a:t>0 breaches</a:t>
+                      </a:r>
+                    </a:p>
+                  </a:txBody>
+                  <a:tcPr marL="54864" marR="36576" marT="22860" marB="22860">
+                    <a:solidFill>
+                      <a:srgbClr val="E8F4EF"/>
                     </a:solidFill>
                   </a:tcPr>
                 </a:tc>
@@ -13873,13 +14215,13 @@
                         </a:defRPr>
                       </a:pPr>
                       <a:r>
-                        <a:t>Monitor</a:t>
-                      </a:r>
-                    </a:p>
-                  </a:txBody>
-                  <a:tcPr marL="54864" marR="36576" marT="22860" marB="22860">
-                    <a:solidFill>
-                      <a:srgbClr val="FFFFFF"/>
+                        <a:t>Pass</a:t>
+                      </a:r>
+                    </a:p>
+                  </a:txBody>
+                  <a:tcPr marL="54864" marR="36576" marT="22860" marB="22860">
+                    <a:solidFill>
+                      <a:srgbClr val="E8F4EF"/>
                     </a:solidFill>
                   </a:tcPr>
                 </a:tc>
@@ -13899,7 +14241,7 @@
                         </a:defRPr>
                       </a:pPr>
                       <a:r>
-                        <a:t>Net-of-cost edge</a:t>
+                        <a:t>PIT evidence</a:t>
                       </a:r>
                     </a:p>
                   </a:txBody>
@@ -13923,7 +14265,7 @@
                         </a:defRPr>
                       </a:pPr>
                       <a:r>
-                        <a:t>Unproven</a:t>
+                        <a:t>7.5 / 15</a:t>
                       </a:r>
                     </a:p>
                   </a:txBody>
@@ -16067,7 +16409,7 @@
       <p:grpSpPr/>
       <p:sp>
         <p:nvSpPr>
-          <p:cNvPr id="2" name="Text: Evidence breadth and provenance"/>
+          <p:cNvPr id="2" name="Text: Evidence breadth and point-in-time progress"/>
           <p:cNvSpPr txBox="1"/>
           <p:nvPr/>
         </p:nvSpPr>
@@ -16099,14 +16441,14 @@
                 </a:solidFill>
                 <a:latin typeface="Aptos Display"/>
               </a:rPr>
-              <a:t>Evidence breadth and provenance</a:t>
-            </a:r>
-          </a:p>
-        </p:txBody>
-      </p:sp>
-      <p:sp>
-        <p:nvSpPr>
-          <p:cNvPr id="3" name="Text: The full universe is broad; the dated validation s"/>
+              <a:t>Evidence breadth and point-in-time progress</a:t>
+            </a:r>
+          </a:p>
+        </p:txBody>
+      </p:sp>
+      <p:sp>
+        <p:nvSpPr>
+          <p:cNvPr id="3" name="Text: Delistings improved; observed historical availabil"/>
           <p:cNvSpPr txBox="1"/>
           <p:nvPr/>
         </p:nvSpPr>
@@ -16138,7 +16480,7 @@
                 </a:solidFill>
                 <a:latin typeface="Aptos"/>
               </a:rPr>
-              <a:t>The full universe is broad; the dated validation set is narrower.</a:t>
+              <a:t>Delistings improved; observed historical availability remains the main gap.</a:t>
             </a:r>
           </a:p>
         </p:txBody>
@@ -16268,7 +16610,7 @@
       </p:sp>
       <p:sp>
         <p:nvSpPr>
-          <p:cNvPr id="7" name="Text: Universe summary and walk-forward manifest"/>
+          <p:cNvPr id="7" name="Text: Universe, walk-forward manifest and PIT evidence c"/>
           <p:cNvSpPr txBox="1"/>
           <p:nvPr/>
         </p:nvSpPr>
@@ -16300,7 +16642,7 @@
                 </a:solidFill>
                 <a:latin typeface="Aptos"/>
               </a:rPr>
-              <a:t>Universe summary and walk-forward manifest</a:t>
+              <a:t>Universe, walk-forward manifest and PIT evidence coverage</a:t>
             </a:r>
           </a:p>
         </p:txBody>
@@ -16397,7 +16739,7 @@
       </p:sp>
       <p:sp>
         <p:nvSpPr>
-          <p:cNvPr id="10" name="Text: 112,570"/>
+          <p:cNvPr id="10" name="Text: 55,504"/>
           <p:cNvSpPr txBox="1"/>
           <p:nvPr/>
         </p:nvSpPr>
@@ -16429,14 +16771,14 @@
                 </a:solidFill>
                 <a:latin typeface="Aptos Display"/>
               </a:rPr>
-              <a:t>112,570</a:t>
-            </a:r>
-          </a:p>
-        </p:txBody>
-      </p:sp>
-      <p:sp>
-        <p:nvSpPr>
-          <p:cNvPr id="11" name="Text: security master"/>
+              <a:t>55,504</a:t>
+            </a:r>
+          </a:p>
+        </p:txBody>
+      </p:sp>
+      <p:sp>
+        <p:nvSpPr>
+          <p:cNvPr id="11" name="Text: active equities"/>
           <p:cNvSpPr txBox="1"/>
           <p:nvPr/>
         </p:nvSpPr>
@@ -16468,7 +16810,7 @@
                 </a:solidFill>
                 <a:latin typeface="Aptos"/>
               </a:rPr>
-              <a:t>security master</a:t>
+              <a:t>active equities</a:t>
             </a:r>
           </a:p>
         </p:txBody>
@@ -16533,11 +16875,11 @@
             <a:avLst/>
           </a:prstGeom>
           <a:solidFill>
-            <a:srgbClr val="14966F"/>
+            <a:srgbClr val="3478A5"/>
           </a:solidFill>
           <a:ln w="10160">
             <a:solidFill>
-              <a:srgbClr val="14966F"/>
+              <a:srgbClr val="3478A5"/>
             </a:solidFill>
           </a:ln>
         </p:spPr>
@@ -16565,7 +16907,7 @@
       </p:sp>
       <p:sp>
         <p:nvSpPr>
-          <p:cNvPr id="14" name="Text: 55,504"/>
+          <p:cNvPr id="14" name="Text: 1,409"/>
           <p:cNvSpPr txBox="1"/>
           <p:nvPr/>
         </p:nvSpPr>
@@ -16597,14 +16939,14 @@
                 </a:solidFill>
                 <a:latin typeface="Aptos Display"/>
               </a:rPr>
-              <a:t>55,504</a:t>
-            </a:r>
-          </a:p>
-        </p:txBody>
-      </p:sp>
-      <p:sp>
-        <p:nvSpPr>
-          <p:cNvPr id="15" name="Text: active equities"/>
+              <a:t>1,409</a:t>
+            </a:r>
+          </a:p>
+        </p:txBody>
+      </p:sp>
+      <p:sp>
+        <p:nvSpPr>
+          <p:cNvPr id="15" name="Text: walk-forward eligible"/>
           <p:cNvSpPr txBox="1"/>
           <p:nvPr/>
         </p:nvSpPr>
@@ -16636,7 +16978,7 @@
                 </a:solidFill>
                 <a:latin typeface="Aptos"/>
               </a:rPr>
-              <a:t>active equities</a:t>
+              <a:t>walk-forward eligible</a:t>
             </a:r>
           </a:p>
         </p:txBody>
@@ -16733,7 +17075,7 @@
       </p:sp>
       <p:sp>
         <p:nvSpPr>
-          <p:cNvPr id="18" name="Text: 1,408"/>
+          <p:cNvPr id="18" name="Text: 156,960"/>
           <p:cNvSpPr txBox="1"/>
           <p:nvPr/>
         </p:nvSpPr>
@@ -16765,14 +17107,14 @@
                 </a:solidFill>
                 <a:latin typeface="Aptos Display"/>
               </a:rPr>
-              <a:t>1,408</a:t>
-            </a:r>
-          </a:p>
-        </p:txBody>
-      </p:sp>
-      <p:sp>
-        <p:nvSpPr>
-          <p:cNvPr id="19" name="Text: walk-forward eligible"/>
+              <a:t>156,960</a:t>
+            </a:r>
+          </a:p>
+        </p:txBody>
+      </p:sp>
+      <p:sp>
+        <p:nvSpPr>
+          <p:cNvPr id="19" name="Text: historical forecasts"/>
           <p:cNvSpPr txBox="1"/>
           <p:nvPr/>
         </p:nvSpPr>
@@ -16804,7 +17146,7 @@
                 </a:solidFill>
                 <a:latin typeface="Aptos"/>
               </a:rPr>
-              <a:t>walk-forward eligible</a:t>
+              <a:t>historical forecasts</a:t>
             </a:r>
           </a:p>
         </p:txBody>
@@ -16869,11 +17211,11 @@
             <a:avLst/>
           </a:prstGeom>
           <a:solidFill>
-            <a:srgbClr val="3478A5"/>
+            <a:srgbClr val="14966F"/>
           </a:solidFill>
           <a:ln w="10160">
             <a:solidFill>
-              <a:srgbClr val="3478A5"/>
+              <a:srgbClr val="14966F"/>
             </a:solidFill>
           </a:ln>
         </p:spPr>
@@ -16901,7 +17243,7 @@
       </p:sp>
       <p:sp>
         <p:nvSpPr>
-          <p:cNvPr id="22" name="Text: 156,764"/>
+          <p:cNvPr id="22" name="Text: 59,183"/>
           <p:cNvSpPr txBox="1"/>
           <p:nvPr/>
         </p:nvSpPr>
@@ -16933,14 +17275,14 @@
                 </a:solidFill>
                 <a:latin typeface="Aptos Display"/>
               </a:rPr>
-              <a:t>156,764</a:t>
-            </a:r>
-          </a:p>
-        </p:txBody>
-      </p:sp>
-      <p:sp>
-        <p:nvSpPr>
-          <p:cNvPr id="23" name="Text: historical forecasts"/>
+              <a:t>59,183</a:t>
+            </a:r>
+          </a:p>
+        </p:txBody>
+      </p:sp>
+      <p:sp>
+        <p:nvSpPr>
+          <p:cNvPr id="23" name="Text: delistings archived"/>
           <p:cNvSpPr txBox="1"/>
           <p:nvPr/>
         </p:nvSpPr>
@@ -16972,7 +17314,7 @@
                 </a:solidFill>
                 <a:latin typeface="Aptos"/>
               </a:rPr>
-              <a:t>historical forecasts</a:t>
+              <a:t>delistings archived</a:t>
             </a:r>
           </a:p>
         </p:txBody>
@@ -17701,7 +18043,7 @@
         </p:nvGraphicFramePr>
         <p:xfrm>
           <a:off x="6336792" y="2587752"/>
-          <a:ext cx="5340095" cy="2852928"/>
+          <a:ext cx="5340094" cy="2852928"/>
         </p:xfrm>
         <a:graphic>
           <a:graphicData uri="http://schemas.openxmlformats.org/drawingml/2006/table">
@@ -17710,9 +18052,9 @@
                 <a:tableStyleId>{5C22544A-7EE6-4342-B048-85BDC9FD1C3A}</a:tableStyleId>
               </a:tblPr>
               <a:tblGrid>
-                <a:gridCol w="1884739"/>
-                <a:gridCol w="1256493"/>
-                <a:gridCol w="2198863"/>
+                <a:gridCol w="2618700"/>
+                <a:gridCol w="1232329"/>
+                <a:gridCol w="1489065"/>
               </a:tblGrid>
               <a:tr h="407561">
                 <a:tc>
@@ -17721,7 +18063,7 @@
                     <a:lstStyle/>
                     <a:p>
                       <a:pPr algn="l">
-                        <a:defRPr sz="1050" b="1">
+                        <a:defRPr sz="1000" b="1">
                           <a:solidFill>
                             <a:srgbClr val="FFFFFF"/>
                           </a:solidFill>
@@ -17729,7 +18071,7 @@
                         </a:defRPr>
                       </a:pPr>
                       <a:r>
-                        <a:t>Evidence</a:t>
+                        <a:t>PIT evidence</a:t>
                       </a:r>
                     </a:p>
                   </a:txBody>
@@ -17745,7 +18087,7 @@
                     <a:lstStyle/>
                     <a:p>
                       <a:pPr algn="l">
-                        <a:defRPr sz="1050" b="1">
+                        <a:defRPr sz="1000" b="1">
                           <a:solidFill>
                             <a:srgbClr val="FFFFFF"/>
                           </a:solidFill>
@@ -17753,7 +18095,7 @@
                         </a:defRPr>
                       </a:pPr>
                       <a:r>
-                        <a:t>Rows</a:t>
+                        <a:t>Coverage</a:t>
                       </a:r>
                     </a:p>
                   </a:txBody>
@@ -17769,7 +18111,7 @@
                     <a:lstStyle/>
                     <a:p>
                       <a:pPr algn="l">
-                        <a:defRPr sz="1050" b="1">
+                        <a:defRPr sz="1000" b="1">
                           <a:solidFill>
                             <a:srgbClr val="FFFFFF"/>
                           </a:solidFill>
@@ -17777,7 +18119,7 @@
                         </a:defRPr>
                       </a:pPr>
                       <a:r>
-                        <a:t>Meaning</a:t>
+                        <a:t>Status</a:t>
                       </a:r>
                     </a:p>
                   </a:txBody>
@@ -17795,21 +18137,21 @@
                     <a:lstStyle/>
                     <a:p>
                       <a:pPr algn="l">
-                        <a:defRPr sz="1050">
-                          <a:solidFill>
-                            <a:srgbClr val="172127"/>
-                          </a:solidFill>
-                          <a:latin typeface="Aptos"/>
-                        </a:defRPr>
-                      </a:pPr>
-                      <a:r>
-                        <a:t>Prices</a:t>
-                      </a:r>
-                    </a:p>
-                  </a:txBody>
-                  <a:tcPr marL="54864" marR="36576" marT="22860" marB="22860">
-                    <a:solidFill>
-                      <a:srgbClr val="FFFFFF"/>
+                        <a:defRPr sz="1000">
+                          <a:solidFill>
+                            <a:srgbClr val="172127"/>
+                          </a:solidFill>
+                          <a:latin typeface="Aptos"/>
+                        </a:defRPr>
+                      </a:pPr>
+                      <a:r>
+                        <a:t>Delisting events</a:t>
+                      </a:r>
+                    </a:p>
+                  </a:txBody>
+                  <a:tcPr marL="54864" marR="36576" marT="22860" marB="22860">
+                    <a:solidFill>
+                      <a:srgbClr val="E8F4EF"/>
                     </a:solidFill>
                   </a:tcPr>
                 </a:tc>
@@ -17819,21 +18161,21 @@
                     <a:lstStyle/>
                     <a:p>
                       <a:pPr algn="l">
-                        <a:defRPr sz="1050">
-                          <a:solidFill>
-                            <a:srgbClr val="172127"/>
-                          </a:solidFill>
-                          <a:latin typeface="Aptos"/>
-                        </a:defRPr>
-                      </a:pPr>
-                      <a:r>
-                        <a:t>3,307,843</a:t>
-                      </a:r>
-                    </a:p>
-                  </a:txBody>
-                  <a:tcPr marL="54864" marR="36576" marT="22860" marB="22860">
-                    <a:solidFill>
-                      <a:srgbClr val="FFFFFF"/>
+                        <a:defRPr sz="1000">
+                          <a:solidFill>
+                            <a:srgbClr val="172127"/>
+                          </a:solidFill>
+                          <a:latin typeface="Aptos"/>
+                        </a:defRPr>
+                      </a:pPr>
+                      <a:r>
+                        <a:t>59,183</a:t>
+                      </a:r>
+                    </a:p>
+                  </a:txBody>
+                  <a:tcPr marL="54864" marR="36576" marT="22860" marB="22860">
+                    <a:solidFill>
+                      <a:srgbClr val="E8F4EF"/>
                     </a:solidFill>
                   </a:tcPr>
                 </a:tc>
@@ -17843,21 +18185,21 @@
                     <a:lstStyle/>
                     <a:p>
                       <a:pPr algn="r">
-                        <a:defRPr sz="1050">
-                          <a:solidFill>
-                            <a:srgbClr val="172127"/>
-                          </a:solidFill>
-                          <a:latin typeface="Aptos"/>
-                        </a:defRPr>
-                      </a:pPr>
-                      <a:r>
-                        <a:t>Observed bars</a:t>
-                      </a:r>
-                    </a:p>
-                  </a:txBody>
-                  <a:tcPr marL="54864" marR="36576" marT="22860" marB="22860">
-                    <a:solidFill>
-                      <a:srgbClr val="FFFFFF"/>
+                        <a:defRPr sz="1000">
+                          <a:solidFill>
+                            <a:srgbClr val="172127"/>
+                          </a:solidFill>
+                          <a:latin typeface="Aptos"/>
+                        </a:defRPr>
+                      </a:pPr>
+                      <a:r>
+                        <a:t>Archived</a:t>
+                      </a:r>
+                    </a:p>
+                  </a:txBody>
+                  <a:tcPr marL="54864" marR="36576" marT="22860" marB="22860">
+                    <a:solidFill>
+                      <a:srgbClr val="E8F4EF"/>
                     </a:solidFill>
                   </a:tcPr>
                 </a:tc>
@@ -17869,15 +18211,15 @@
                     <a:lstStyle/>
                     <a:p>
                       <a:pPr algn="l">
-                        <a:defRPr sz="1050">
-                          <a:solidFill>
-                            <a:srgbClr val="172127"/>
-                          </a:solidFill>
-                          <a:latin typeface="Aptos"/>
-                        </a:defRPr>
-                      </a:pPr>
-                      <a:r>
-                        <a:t>Statements</a:t>
+                        <a:defRPr sz="1000">
+                          <a:solidFill>
+                            <a:srgbClr val="172127"/>
+                          </a:solidFill>
+                          <a:latin typeface="Aptos"/>
+                        </a:defRPr>
+                      </a:pPr>
+                      <a:r>
+                        <a:t>Fundamentals with filing date</a:t>
                       </a:r>
                     </a:p>
                   </a:txBody>
@@ -17893,15 +18235,15 @@
                     <a:lstStyle/>
                     <a:p>
                       <a:pPr algn="l">
-                        <a:defRPr sz="1050">
-                          <a:solidFill>
-                            <a:srgbClr val="172127"/>
-                          </a:solidFill>
-                          <a:latin typeface="Aptos"/>
-                        </a:defRPr>
-                      </a:pPr>
-                      <a:r>
-                        <a:t>7,632</a:t>
+                        <a:defRPr sz="1000">
+                          <a:solidFill>
+                            <a:srgbClr val="172127"/>
+                          </a:solidFill>
+                          <a:latin typeface="Aptos"/>
+                        </a:defRPr>
+                      </a:pPr>
+                      <a:r>
+                        <a:t>7,081</a:t>
                       </a:r>
                     </a:p>
                   </a:txBody>
@@ -17917,15 +18259,15 @@
                     <a:lstStyle/>
                     <a:p>
                       <a:pPr algn="r">
-                        <a:defRPr sz="1050">
-                          <a:solidFill>
-                            <a:srgbClr val="172127"/>
-                          </a:solidFill>
-                          <a:latin typeface="Aptos"/>
-                        </a:defRPr>
-                      </a:pPr>
-                      <a:r>
-                        <a:t>Reported annuals</a:t>
+                        <a:defRPr sz="1000">
+                          <a:solidFill>
+                            <a:srgbClr val="172127"/>
+                          </a:solidFill>
+                          <a:latin typeface="Aptos"/>
+                        </a:defRPr>
+                      </a:pPr>
+                      <a:r>
+                        <a:t>Mostly reconstructed</a:t>
                       </a:r>
                     </a:p>
                   </a:txBody>
@@ -17943,15 +18285,15 @@
                     <a:lstStyle/>
                     <a:p>
                       <a:pPr algn="l">
-                        <a:defRPr sz="1050">
-                          <a:solidFill>
-                            <a:srgbClr val="172127"/>
-                          </a:solidFill>
-                          <a:latin typeface="Aptos"/>
-                        </a:defRPr>
-                      </a:pPr>
-                      <a:r>
-                        <a:t>Aligned outcomes</a:t>
+                        <a:defRPr sz="1000">
+                          <a:solidFill>
+                            <a:srgbClr val="172127"/>
+                          </a:solidFill>
+                          <a:latin typeface="Aptos"/>
+                        </a:defRPr>
+                      </a:pPr>
+                      <a:r>
+                        <a:t>Observed acceptance times</a:t>
                       </a:r>
                     </a:p>
                   </a:txBody>
@@ -17967,15 +18309,15 @@
                     <a:lstStyle/>
                     <a:p>
                       <a:pPr algn="l">
-                        <a:defRPr sz="1050">
-                          <a:solidFill>
-                            <a:srgbClr val="172127"/>
-                          </a:solidFill>
-                          <a:latin typeface="Aptos"/>
-                        </a:defRPr>
-                      </a:pPr>
-                      <a:r>
-                        <a:t>156,312</a:t>
+                        <a:defRPr sz="1000">
+                          <a:solidFill>
+                            <a:srgbClr val="172127"/>
+                          </a:solidFill>
+                          <a:latin typeface="Aptos"/>
+                        </a:defRPr>
+                      </a:pPr>
+                      <a:r>
+                        <a:t>0</a:t>
                       </a:r>
                     </a:p>
                   </a:txBody>
@@ -17991,15 +18333,15 @@
                     <a:lstStyle/>
                     <a:p>
                       <a:pPr algn="r">
-                        <a:defRPr sz="1050">
-                          <a:solidFill>
-                            <a:srgbClr val="172127"/>
-                          </a:solidFill>
-                          <a:latin typeface="Aptos"/>
-                        </a:defRPr>
-                      </a:pPr>
-                      <a:r>
-                        <a:t>99.7% matched</a:t>
+                        <a:defRPr sz="1000">
+                          <a:solidFill>
+                            <a:srgbClr val="172127"/>
+                          </a:solidFill>
+                          <a:latin typeface="Aptos"/>
+                        </a:defRPr>
+                      </a:pPr>
+                      <a:r>
+                        <a:t>Missing</a:t>
                       </a:r>
                     </a:p>
                   </a:txBody>
@@ -18017,15 +18359,15 @@
                     <a:lstStyle/>
                     <a:p>
                       <a:pPr algn="l">
-                        <a:defRPr sz="1050">
-                          <a:solidFill>
-                            <a:srgbClr val="172127"/>
-                          </a:solidFill>
-                          <a:latin typeface="Aptos"/>
-                        </a:defRPr>
-                      </a:pPr>
-                      <a:r>
-                        <a:t>Risk observations</a:t>
+                        <a:defRPr sz="1000">
+                          <a:solidFill>
+                            <a:srgbClr val="172127"/>
+                          </a:solidFill>
+                          <a:latin typeface="Aptos"/>
+                        </a:defRPr>
+                      </a:pPr>
+                      <a:r>
+                        <a:t>Dated membership events</a:t>
                       </a:r>
                     </a:p>
                   </a:txBody>
@@ -18041,15 +18383,15 @@
                     <a:lstStyle/>
                     <a:p>
                       <a:pPr algn="l">
-                        <a:defRPr sz="1050">
-                          <a:solidFill>
-                            <a:srgbClr val="172127"/>
-                          </a:solidFill>
-                          <a:latin typeface="Aptos"/>
-                        </a:defRPr>
-                      </a:pPr>
-                      <a:r>
-                        <a:t>1,141</a:t>
+                        <a:defRPr sz="1000">
+                          <a:solidFill>
+                            <a:srgbClr val="172127"/>
+                          </a:solidFill>
+                          <a:latin typeface="Aptos"/>
+                        </a:defRPr>
+                      </a:pPr>
+                      <a:r>
+                        <a:t>0</a:t>
                       </a:r>
                     </a:p>
                   </a:txBody>
@@ -18065,15 +18407,15 @@
                     <a:lstStyle/>
                     <a:p>
                       <a:pPr algn="r">
-                        <a:defRPr sz="1050">
-                          <a:solidFill>
-                            <a:srgbClr val="172127"/>
-                          </a:solidFill>
-                          <a:latin typeface="Aptos"/>
-                        </a:defRPr>
-                      </a:pPr>
-                      <a:r>
-                        <a:t>Daily checks</a:t>
+                        <a:defRPr sz="1000">
+                          <a:solidFill>
+                            <a:srgbClr val="172127"/>
+                          </a:solidFill>
+                          <a:latin typeface="Aptos"/>
+                        </a:defRPr>
+                      </a:pPr>
+                      <a:r>
+                        <a:t>Missing</a:t>
                       </a:r>
                     </a:p>
                   </a:txBody>
@@ -18091,21 +18433,21 @@
                     <a:lstStyle/>
                     <a:p>
                       <a:pPr algn="l">
-                        <a:defRPr sz="1050">
-                          <a:solidFill>
-                            <a:srgbClr val="172127"/>
-                          </a:solidFill>
-                          <a:latin typeface="Aptos"/>
-                        </a:defRPr>
-                      </a:pPr>
-                      <a:r>
-                        <a:t>Chronology breaches</a:t>
-                      </a:r>
-                    </a:p>
-                  </a:txBody>
-                  <a:tcPr marL="54864" marR="36576" marT="22860" marB="22860">
-                    <a:solidFill>
-                      <a:srgbClr val="E8F4EF"/>
+                        <a:defRPr sz="1000">
+                          <a:solidFill>
+                            <a:srgbClr val="172127"/>
+                          </a:solidFill>
+                          <a:latin typeface="Aptos"/>
+                        </a:defRPr>
+                      </a:pPr>
+                      <a:r>
+                        <a:t>Inactive names with prices</a:t>
+                      </a:r>
+                    </a:p>
+                  </a:txBody>
+                  <a:tcPr marL="54864" marR="36576" marT="22860" marB="22860">
+                    <a:solidFill>
+                      <a:srgbClr val="FFFFFF"/>
                     </a:solidFill>
                   </a:tcPr>
                 </a:tc>
@@ -18115,7 +18457,7 @@
                     <a:lstStyle/>
                     <a:p>
                       <a:pPr algn="l">
-                        <a:defRPr sz="1050">
+                        <a:defRPr sz="1000">
                           <a:solidFill>
                             <a:srgbClr val="172127"/>
                           </a:solidFill>
@@ -18129,7 +18471,7 @@
                   </a:txBody>
                   <a:tcPr marL="54864" marR="36576" marT="22860" marB="22860">
                     <a:solidFill>
-                      <a:srgbClr val="E8F4EF"/>
+                      <a:srgbClr val="FFFFFF"/>
                     </a:solidFill>
                   </a:tcPr>
                 </a:tc>
@@ -18139,21 +18481,21 @@
                     <a:lstStyle/>
                     <a:p>
                       <a:pPr algn="r">
-                        <a:defRPr sz="1050">
-                          <a:solidFill>
-                            <a:srgbClr val="172127"/>
-                          </a:solidFill>
-                          <a:latin typeface="Aptos"/>
-                        </a:defRPr>
-                      </a:pPr>
-                      <a:r>
-                        <a:t>Pass</a:t>
-                      </a:r>
-                    </a:p>
-                  </a:txBody>
-                  <a:tcPr marL="54864" marR="36576" marT="22860" marB="22860">
-                    <a:solidFill>
-                      <a:srgbClr val="E8F4EF"/>
+                        <a:defRPr sz="1000">
+                          <a:solidFill>
+                            <a:srgbClr val="172127"/>
+                          </a:solidFill>
+                          <a:latin typeface="Aptos"/>
+                        </a:defRPr>
+                      </a:pPr>
+                      <a:r>
+                        <a:t>Missing</a:t>
+                      </a:r>
+                    </a:p>
+                  </a:txBody>
+                  <a:tcPr marL="54864" marR="36576" marT="22860" marB="22860">
+                    <a:solidFill>
+                      <a:srgbClr val="FFFFFF"/>
                     </a:solidFill>
                   </a:tcPr>
                 </a:tc>
@@ -18165,21 +18507,21 @@
                     <a:lstStyle/>
                     <a:p>
                       <a:pPr algn="l">
-                        <a:defRPr sz="1050">
-                          <a:solidFill>
-                            <a:srgbClr val="172127"/>
-                          </a:solidFill>
-                          <a:latin typeface="Aptos"/>
-                        </a:defRPr>
-                      </a:pPr>
-                      <a:r>
-                        <a:t>Hard breaches</a:t>
-                      </a:r>
-                    </a:p>
-                  </a:txBody>
-                  <a:tcPr marL="54864" marR="36576" marT="22860" marB="22860">
-                    <a:solidFill>
-                      <a:srgbClr val="E8F4EF"/>
+                        <a:defRPr sz="1000">
+                          <a:solidFill>
+                            <a:srgbClr val="172127"/>
+                          </a:solidFill>
+                          <a:latin typeface="Aptos"/>
+                        </a:defRPr>
+                      </a:pPr>
+                      <a:r>
+                        <a:t>Names with historical volume</a:t>
+                      </a:r>
+                    </a:p>
+                  </a:txBody>
+                  <a:tcPr marL="54864" marR="36576" marT="22860" marB="22860">
+                    <a:solidFill>
+                      <a:srgbClr val="FFFFFF"/>
                     </a:solidFill>
                   </a:tcPr>
                 </a:tc>
@@ -18189,7 +18531,7 @@
                     <a:lstStyle/>
                     <a:p>
                       <a:pPr algn="l">
-                        <a:defRPr sz="1050">
+                        <a:defRPr sz="1000">
                           <a:solidFill>
                             <a:srgbClr val="172127"/>
                           </a:solidFill>
@@ -18203,7 +18545,7 @@
                   </a:txBody>
                   <a:tcPr marL="54864" marR="36576" marT="22860" marB="22860">
                     <a:solidFill>
-                      <a:srgbClr val="E8F4EF"/>
+                      <a:srgbClr val="FFFFFF"/>
                     </a:solidFill>
                   </a:tcPr>
                 </a:tc>
@@ -18213,21 +18555,21 @@
                     <a:lstStyle/>
                     <a:p>
                       <a:pPr algn="r">
-                        <a:defRPr sz="1050">
-                          <a:solidFill>
-                            <a:srgbClr val="172127"/>
-                          </a:solidFill>
-                          <a:latin typeface="Aptos"/>
-                        </a:defRPr>
-                      </a:pPr>
-                      <a:r>
-                        <a:t>Pass</a:t>
-                      </a:r>
-                    </a:p>
-                  </a:txBody>
-                  <a:tcPr marL="54864" marR="36576" marT="22860" marB="22860">
-                    <a:solidFill>
-                      <a:srgbClr val="E8F4EF"/>
+                        <a:defRPr sz="1000">
+                          <a:solidFill>
+                            <a:srgbClr val="172127"/>
+                          </a:solidFill>
+                          <a:latin typeface="Aptos"/>
+                        </a:defRPr>
+                      </a:pPr>
+                      <a:r>
+                        <a:t>Missing</a:t>
+                      </a:r>
+                    </a:p>
+                  </a:txBody>
+                  <a:tcPr marL="54864" marR="36576" marT="22860" marB="22860">
+                    <a:solidFill>
+                      <a:srgbClr val="FFFFFF"/>
                     </a:solidFill>
                   </a:tcPr>
                 </a:tc>
@@ -18328,7 +18670,7 @@
       </p:sp>
       <p:sp>
         <p:nvSpPr>
-          <p:cNvPr id="28" name="Text: Important boundary: Historical filing dates are co"/>
+          <p:cNvPr id="28" name="Text: Provider outcome: EODHD added 59,183 delistings; N"/>
           <p:cNvSpPr txBox="1"/>
           <p:nvPr/>
         </p:nvSpPr>
@@ -18360,7 +18702,7 @@
                 </a:solidFill>
                 <a:latin typeface="Aptos"/>
               </a:rPr>
-              <a:t>Important boundary: Historical filing dates are conservatively reconstructed where observed timestamps are unavailable. This caps approval at conditional, even though chronology checks pass.</a:t>
+              <a:t>Provider outcome: EODHD added 59,183 delistings; Nasdaq entitlement yielded five usable rows; Beam was unavailable; SEC blocked this runner. Unavailable history is never treated as observed.</a:t>
             </a:r>
           </a:p>
         </p:txBody>
@@ -25013,7 +25355,7 @@
       </p:sp>
       <p:sp>
         <p:nvSpPr>
-          <p:cNvPr id="12" name="Text: $186.1m grows to $352.9m; net PnL is $166.9m after"/>
+          <p:cNvPr id="12" name="Text: $186.1m grows to $355.3m; net PnL is $169.3m after"/>
           <p:cNvSpPr txBox="1"/>
           <p:nvPr/>
         </p:nvSpPr>
@@ -25045,7 +25387,7 @@
                 </a:solidFill>
                 <a:latin typeface="Aptos"/>
               </a:rPr>
-              <a:t>$186.1m grows to $352.9m; net PnL is $166.9m after trading costs and before the bank fee.</a:t>
+              <a:t>$186.1m grows to $355.3m; net PnL is $169.3m after trading costs and before the bank fee.</a:t>
             </a:r>
           </a:p>
         </p:txBody>
@@ -25087,7 +25429,7 @@
               </a:defRPr>
             </a:pPr>
             <a:r>
-              <a:t>• Net annualised return: 13.7%</a:t>
+              <a:t>• Net annualised return: 13.8%</a:t>
             </a:r>
           </a:p>
           <a:p>
@@ -25106,7 +25448,7 @@
               </a:defRPr>
             </a:pPr>
             <a:r>
-              <a:t>• Sharpe ratio: 1.16</a:t>
+              <a:t>• Sharpe ratio: 1.26</a:t>
             </a:r>
           </a:p>
           <a:p>
@@ -25125,7 +25467,7 @@
               </a:defRPr>
             </a:pPr>
             <a:r>
-              <a:t>• Maximum drawdown: -13.7%</a:t>
+              <a:t>• Maximum drawdown: -13.0%</a:t>
             </a:r>
           </a:p>
           <a:p>
@@ -25144,7 +25486,7 @@
               </a:defRPr>
             </a:pPr>
             <a:r>
-              <a:t>• Positive months: 63.3%</a:t>
+              <a:t>• Positive months: 65.0%</a:t>
             </a:r>
           </a:p>
         </p:txBody>
@@ -25738,7 +26080,7 @@
       </p:sp>
       <p:sp>
         <p:nvSpPr>
-          <p:cNvPr id="12" name="Text: Wolf Sharpe was 1.16 and drawdown was 13.72%, bett"/>
+          <p:cNvPr id="12" name="Text: Wolf Sharpe was 1.26 and drawdown was 13.0%, bette"/>
           <p:cNvSpPr txBox="1"/>
           <p:nvPr/>
         </p:nvSpPr>
@@ -25770,7 +26112,7 @@
                 </a:solidFill>
                 <a:latin typeface="Aptos"/>
               </a:rPr>
-              <a:t>Wolf Sharpe was 1.16 and drawdown was 13.72%, better than both simple controls on these risk measures.</a:t>
+              <a:t>Wolf Sharpe was 1.26 and drawdown was 13.0%, better than both simple controls on these risk measures.</a:t>
             </a:r>
           </a:p>
         </p:txBody>
@@ -25906,7 +26248,7 @@
       </p:sp>
       <p:sp>
         <p:nvSpPr>
-          <p:cNvPr id="16" name="Text: Equal weight returned 14.84% versus Wolf at 13.66%"/>
+          <p:cNvPr id="16" name="Text: Equal weight returned 14.88% versus Wolf at 13.81%"/>
           <p:cNvSpPr txBox="1"/>
           <p:nvPr/>
         </p:nvSpPr>
@@ -25938,7 +26280,7 @@
                 </a:solidFill>
                 <a:latin typeface="Aptos"/>
               </a:rPr>
-              <a:t>Equal weight returned 14.84% versus Wolf at 13.66%. The model did not beat the simplest control on net return.</a:t>
+              <a:t>Equal weight returned 14.88% versus Wolf at 13.81%. The model did not beat the simplest control on net return.</a:t>
             </a:r>
           </a:p>
         </p:txBody>

</xml_diff>

<commit_message>
Add production PIT ingestion and DRL guardrails
</commit_message>
<xml_diff>
--- a/reports/presentations/wolf_investment_principal/wolf_quant_model_ic_briefing.pptx
+++ b/reports/presentations/wolf_investment_principal/wolf_quant_model_ic_briefing.pptx
@@ -16305,7 +16305,7 @@
       </p:sp>
       <p:sp>
         <p:nvSpPr>
-          <p:cNvPr id="44" name="Text: The current DRL proposal was rejected because turn"/>
+          <p:cNvPr id="44" name="Text: Five real PPO seeds failed the validation hurdle a"/>
           <p:cNvSpPr txBox="1"/>
           <p:nvPr/>
         </p:nvSpPr>
@@ -16337,7 +16337,7 @@
                 </a:solidFill>
                 <a:latin typeface="Aptos"/>
               </a:rPr>
-              <a:t>The current DRL proposal was rejected because turnover exceeded its hard limit. The CVaR baseline remained selected.</a:t>
+              <a:t>Five real PPO seeds failed the validation hurdle and did not improve untouched-test Sharpe. The CVaR baseline remains at 100%.</a:t>
             </a:r>
           </a:p>
         </p:txBody>

</xml_diff>

<commit_message>
Complete bounded production validation and publish evidence
Add resumable bounded-memory orchestration, exact DuckDB summaries, production PIT coverage, development-locked risk calibration, and fail-closed multi-seed DRL evaluation. Publish the refreshed 1997 replay, statistical diagnostics, 87.5/100 validation package, overnight evidence, and visually verified investment-principal deck. Verified with 403 passing tests.
</commit_message>
<xml_diff>
--- a/reports/presentations/wolf_investment_principal/wolf_quant_model_ic_briefing.pptx
+++ b/reports/presentations/wolf_investment_principal/wolf_quant_model_ic_briefing.pptx
@@ -3414,7 +3414,7 @@
         <p:spPr>
           <a:xfrm>
             <a:off x="978408" y="4956048"/>
-            <a:ext cx="2148840" cy="274320"/>
+            <a:ext cx="2148840" cy="329184"/>
           </a:xfrm>
           <a:prstGeom prst="rect">
             <a:avLst/>
@@ -3537,7 +3537,7 @@
         <p:spPr>
           <a:xfrm>
             <a:off x="3739896" y="4956048"/>
-            <a:ext cx="2148840" cy="274320"/>
+            <a:ext cx="2148840" cy="329184"/>
           </a:xfrm>
           <a:prstGeom prst="rect">
             <a:avLst/>
@@ -3660,7 +3660,7 @@
         <p:spPr>
           <a:xfrm>
             <a:off x="6501384" y="4956048"/>
-            <a:ext cx="2148840" cy="274320"/>
+            <a:ext cx="2148840" cy="329184"/>
           </a:xfrm>
           <a:prstGeom prst="rect">
             <a:avLst/>
@@ -3783,7 +3783,7 @@
         <p:spPr>
           <a:xfrm>
             <a:off x="9262872" y="4956048"/>
-            <a:ext cx="2148840" cy="274320"/>
+            <a:ext cx="2148840" cy="329184"/>
           </a:xfrm>
           <a:prstGeom prst="rect">
             <a:avLst/>
@@ -4343,7 +4343,7 @@
                         </a:defRPr>
                       </a:pPr>
                       <a:r>
-                        <a:t>3.43%</a:t>
+                        <a:t>2.67%</a:t>
                       </a:r>
                     </a:p>
                   </a:txBody>
@@ -4367,7 +4367,7 @@
                         </a:defRPr>
                       </a:pPr>
                       <a:r>
-                        <a:t>4.40%</a:t>
+                        <a:t>5.33%</a:t>
                       </a:r>
                     </a:p>
                   </a:txBody>
@@ -4391,7 +4391,7 @@
                         </a:defRPr>
                       </a:pPr>
                       <a:r>
-                        <a:t>0.108</a:t>
+                        <a:t>0.036</a:t>
                       </a:r>
                     </a:p>
                   </a:txBody>
@@ -4465,7 +4465,7 @@
                         </a:defRPr>
                       </a:pPr>
                       <a:r>
-                        <a:t>-1.24%</a:t>
+                        <a:t>-2.44%</a:t>
                       </a:r>
                     </a:p>
                   </a:txBody>
@@ -4489,7 +4489,7 @@
                         </a:defRPr>
                       </a:pPr>
                       <a:r>
-                        <a:t>3.29%</a:t>
+                        <a:t>4.38%</a:t>
                       </a:r>
                     </a:p>
                   </a:txBody>
@@ -4513,7 +4513,7 @@
                         </a:defRPr>
                       </a:pPr>
                       <a:r>
-                        <a:t>0.312</a:t>
+                        <a:t>0.169</a:t>
                       </a:r>
                     </a:p>
                   </a:txBody>
@@ -5559,7 +5559,7 @@
                         </a:defRPr>
                       </a:pPr>
                       <a:r>
-                        <a:t>13.0%</a:t>
+                        <a:t>13.7%</a:t>
                       </a:r>
                     </a:p>
                   </a:txBody>
@@ -5607,7 +5607,7 @@
                         </a:defRPr>
                       </a:pPr>
                       <a:r>
-                        <a:t>-41.2%</a:t>
+                        <a:t>-47.4%</a:t>
                       </a:r>
                     </a:p>
                   </a:txBody>
@@ -5631,7 +5631,7 @@
                         </a:defRPr>
                       </a:pPr>
                       <a:r>
-                        <a:t>$6.8bn</a:t>
+                        <a:t>$8.2bn</a:t>
                       </a:r>
                     </a:p>
                   </a:txBody>
@@ -5705,7 +5705,7 @@
                         </a:defRPr>
                       </a:pPr>
                       <a:r>
-                        <a:t>10.9%</a:t>
+                        <a:t>10.4%</a:t>
                       </a:r>
                     </a:p>
                   </a:txBody>
@@ -5729,7 +5729,7 @@
                         </a:defRPr>
                       </a:pPr>
                       <a:r>
-                        <a:t>0.77</a:t>
+                        <a:t>0.74</a:t>
                       </a:r>
                     </a:p>
                   </a:txBody>
@@ -5753,7 +5753,7 @@
                         </a:defRPr>
                       </a:pPr>
                       <a:r>
-                        <a:t>-30.6%</a:t>
+                        <a:t>-29.1%</a:t>
                       </a:r>
                     </a:p>
                   </a:txBody>
@@ -5777,7 +5777,7 @@
                         </a:defRPr>
                       </a:pPr>
                       <a:r>
-                        <a:t>$2.1m</a:t>
+                        <a:t>$1.9m</a:t>
                       </a:r>
                     </a:p>
                   </a:txBody>
@@ -5851,7 +5851,7 @@
                         </a:defRPr>
                       </a:pPr>
                       <a:r>
-                        <a:t>9.5%</a:t>
+                        <a:t>5.5%</a:t>
                       </a:r>
                     </a:p>
                   </a:txBody>
@@ -5875,7 +5875,7 @@
                         </a:defRPr>
                       </a:pPr>
                       <a:r>
-                        <a:t>0.81</a:t>
+                        <a:t>0.63</a:t>
                       </a:r>
                     </a:p>
                   </a:txBody>
@@ -5899,7 +5899,7 @@
                         </a:defRPr>
                       </a:pPr>
                       <a:r>
-                        <a:t>-20.9%</a:t>
+                        <a:t>-13.3%</a:t>
                       </a:r>
                     </a:p>
                   </a:txBody>
@@ -5923,7 +5923,7 @@
                         </a:defRPr>
                       </a:pPr>
                       <a:r>
-                        <a:t>$1.5m</a:t>
+                        <a:t>$488.3k</a:t>
                       </a:r>
                     </a:p>
                   </a:txBody>
@@ -5997,7 +5997,7 @@
                         </a:defRPr>
                       </a:pPr>
                       <a:r>
-                        <a:t>9.1%</a:t>
+                        <a:t>8.3%</a:t>
                       </a:r>
                     </a:p>
                   </a:txBody>
@@ -6021,7 +6021,7 @@
                         </a:defRPr>
                       </a:pPr>
                       <a:r>
-                        <a:t>0.65</a:t>
+                        <a:t>0.58</a:t>
                       </a:r>
                     </a:p>
                   </a:txBody>
@@ -6045,7 +6045,7 @@
                         </a:defRPr>
                       </a:pPr>
                       <a:r>
-                        <a:t>-28.4%</a:t>
+                        <a:t>-37.3%</a:t>
                       </a:r>
                     </a:p>
                   </a:txBody>
@@ -6069,7 +6069,7 @@
                         </a:defRPr>
                       </a:pPr>
                       <a:r>
-                        <a:t>$2.4bn</a:t>
+                        <a:t>$2.0bn</a:t>
                       </a:r>
                     </a:p>
                   </a:txBody>
@@ -6271,7 +6271,7 @@
                 </a:solidFill>
                 <a:latin typeface="Aptos"/>
               </a:rPr>
-              <a:t>Current Portfolio PnL: $8.8bn. Final Resolved PnL: $2.2bn. Risk Parity led the independent optimisers.</a:t>
+              <a:t>Current Portfolio PnL: $8.8bn. Final Resolved PnL: $1.8bn. Risk Parity led the independent optimisers.</a:t>
             </a:r>
           </a:p>
         </p:txBody>
@@ -6285,7 +6285,7 @@
         <p:spPr>
           <a:xfrm>
             <a:off x="6236208" y="4791456"/>
-            <a:ext cx="5440680" cy="1143000"/>
+            <a:ext cx="5440680" cy="1197864"/>
           </a:xfrm>
           <a:prstGeom prst="rect">
             <a:avLst/>
@@ -6330,7 +6330,7 @@
         <p:spPr>
           <a:xfrm>
             <a:off x="6236208" y="4791456"/>
-            <a:ext cx="54864" cy="1143000"/>
+            <a:ext cx="54864" cy="1197864"/>
           </a:xfrm>
           <a:prstGeom prst="rect">
             <a:avLst/>
@@ -6414,7 +6414,7 @@
         <p:spPr>
           <a:xfrm>
             <a:off x="6437376" y="5312664"/>
-            <a:ext cx="5111496" cy="502920"/>
+            <a:ext cx="5111496" cy="557784"/>
           </a:xfrm>
           <a:prstGeom prst="rect">
             <a:avLst/>
@@ -8232,7 +8232,7 @@
                         </a:defRPr>
                       </a:pPr>
                       <a:r>
-                        <a:t>62/1152</a:t>
+                        <a:t>50/1158</a:t>
                       </a:r>
                     </a:p>
                   </a:txBody>
@@ -8256,7 +8256,7 @@
                         </a:defRPr>
                       </a:pPr>
                       <a:r>
-                        <a:t>0.557</a:t>
+                        <a:t>0.276</a:t>
                       </a:r>
                     </a:p>
                   </a:txBody>
@@ -8280,7 +8280,7 @@
                         </a:defRPr>
                       </a:pPr>
                       <a:r>
-                        <a:t>0.367</a:t>
+                        <a:t>0.080</a:t>
                       </a:r>
                     </a:p>
                   </a:txBody>
@@ -8354,7 +8354,7 @@
                         </a:defRPr>
                       </a:pPr>
                       <a:r>
-                        <a:t>10/1152</a:t>
+                        <a:t>15/1158</a:t>
                       </a:r>
                     </a:p>
                   </a:txBody>
@@ -8378,7 +8378,7 @@
                         </a:defRPr>
                       </a:pPr>
                       <a:r>
-                        <a:t>0.645</a:t>
+                        <a:t>0.334</a:t>
                       </a:r>
                     </a:p>
                   </a:txBody>
@@ -8402,7 +8402,7 @@
                         </a:defRPr>
                       </a:pPr>
                       <a:r>
-                        <a:t>0.072</a:t>
+                        <a:t>0.530</a:t>
                       </a:r>
                     </a:p>
                   </a:txBody>
@@ -8476,7 +8476,7 @@
                         </a:defRPr>
                       </a:pPr>
                       <a:r>
-                        <a:t>21/460</a:t>
+                        <a:t>15/463</a:t>
                       </a:r>
                     </a:p>
                   </a:txBody>
@@ -8500,7 +8500,7 @@
                         </a:defRPr>
                       </a:pPr>
                       <a:r>
-                        <a:t>0.664</a:t>
+                        <a:t>0.064</a:t>
                       </a:r>
                     </a:p>
                   </a:txBody>
@@ -8524,7 +8524,7 @@
                         </a:defRPr>
                       </a:pPr>
                       <a:r>
-                        <a:t>0.074</a:t>
+                        <a:t>0.086</a:t>
                       </a:r>
                     </a:p>
                   </a:txBody>
@@ -8598,7 +8598,7 @@
                         </a:defRPr>
                       </a:pPr>
                       <a:r>
-                        <a:t>3/460</a:t>
+                        <a:t>2/463</a:t>
                       </a:r>
                     </a:p>
                   </a:txBody>
@@ -8622,7 +8622,7 @@
                         </a:defRPr>
                       </a:pPr>
                       <a:r>
-                        <a:t>0.423</a:t>
+                        <a:t>0.166</a:t>
                       </a:r>
                     </a:p>
                   </a:txBody>
@@ -8646,7 +8646,7 @@
                         </a:defRPr>
                       </a:pPr>
                       <a:r>
-                        <a:t>0.843</a:t>
+                        <a:t>0.895</a:t>
                       </a:r>
                     </a:p>
                   </a:txBody>
@@ -8670,7 +8670,7 @@
         <p:spPr>
           <a:xfrm>
             <a:off x="6336792" y="4251960"/>
-            <a:ext cx="5340096" cy="1325880"/>
+            <a:ext cx="5340096" cy="1371600"/>
           </a:xfrm>
           <a:prstGeom prst="rect">
             <a:avLst/>
@@ -8715,7 +8715,7 @@
         <p:spPr>
           <a:xfrm>
             <a:off x="6336792" y="4251960"/>
-            <a:ext cx="54864" cy="1325880"/>
+            <a:ext cx="54864" cy="1371600"/>
           </a:xfrm>
           <a:prstGeom prst="rect">
             <a:avLst/>
@@ -8753,7 +8753,7 @@
       </p:sp>
       <p:sp>
         <p:nvSpPr>
-          <p:cNvPr id="13" name="Text: Adaptive risk stack: 15 / 15"/>
+          <p:cNvPr id="13" name="Text: Development-locked risk stack: 15 / 15"/>
           <p:cNvSpPr txBox="1"/>
           <p:nvPr/>
         </p:nvSpPr>
@@ -8785,7 +8785,7 @@
                 </a:solidFill>
                 <a:latin typeface="Aptos Display"/>
               </a:rPr>
-              <a:t>Adaptive risk stack: 15 / 15</a:t>
+              <a:t>Development-locked risk stack: 15 / 15</a:t>
             </a:r>
           </a:p>
         </p:txBody>
@@ -8799,7 +8799,7 @@
         <p:spPr>
           <a:xfrm>
             <a:off x="6537959" y="4773168"/>
-            <a:ext cx="5010912" cy="685800"/>
+            <a:ext cx="5010912" cy="731520"/>
           </a:xfrm>
           <a:prstGeom prst="rect">
             <a:avLst/>
@@ -8824,14 +8824,14 @@
                 </a:solidFill>
                 <a:latin typeface="Aptos"/>
               </a:rPr>
-              <a:t>DCC-IGARCH Student-t, filtered historical simulation, EWMA Normal and EWMA Student-t are selected using trailing data. The holdout is chronological reconstructed evidence, not a pristine future shadow period.</a:t>
-            </a:r>
-          </a:p>
-        </p:txBody>
-      </p:sp>
-      <p:sp>
-        <p:nvSpPr>
-          <p:cNvPr id="15" name="Text: Overall 87.5/100  |  6 pass  |  PIT and portfolio "/>
+              <a:t>DCC-IGARCH Student-t, filtered historical simulation, EWMA Normal and EWMA Student-t are selected using trailing data. Development data selected a 1.075x scale and 1.40x buffer for 1 day after a breach. The holdout is chronological reconstructed evidence, not a pristine future shadow period.</a:t>
+            </a:r>
+          </a:p>
+        </p:txBody>
+      </p:sp>
+      <p:sp>
+        <p:nvSpPr>
+          <p:cNvPr id="15" name="Text: Overall 87.5/100  |  6 pass  |  2 warnings  |  0 c"/>
           <p:cNvSpPr txBox="1"/>
           <p:nvPr/>
         </p:nvSpPr>
@@ -8863,7 +8863,7 @@
                 </a:solidFill>
                 <a:latin typeface="Aptos"/>
               </a:rPr>
-              <a:t>Overall 87.5/100  |  6 pass  |  PIT and portfolio warnings  |  0 critical failures  |  full local suite passed</a:t>
+              <a:t>Overall 87.5/100  |  6 pass  |  2 warnings  |  0 critical failures  |  full local suite passed</a:t>
             </a:r>
           </a:p>
         </p:txBody>
@@ -9250,7 +9250,7 @@
       </p:sp>
       <p:sp>
         <p:nvSpPr>
-          <p:cNvPr id="11" name="Text: 1.28%"/>
+          <p:cNvPr id="11" name="Text: 0.82%"/>
           <p:cNvSpPr txBox="1"/>
           <p:nvPr/>
         </p:nvSpPr>
@@ -9282,7 +9282,7 @@
                 </a:solidFill>
                 <a:latin typeface="Aptos Display"/>
               </a:rPr>
-              <a:t>1.28%</a:t>
+              <a:t>0.82%</a:t>
             </a:r>
           </a:p>
         </p:txBody>
@@ -9418,7 +9418,7 @@
       </p:sp>
       <p:sp>
         <p:nvSpPr>
-          <p:cNvPr id="15" name="Text: 1.33x"/>
+          <p:cNvPr id="15" name="Text: 1.10x"/>
           <p:cNvSpPr txBox="1"/>
           <p:nvPr/>
         </p:nvSpPr>
@@ -9450,7 +9450,7 @@
                 </a:solidFill>
                 <a:latin typeface="Aptos Display"/>
               </a:rPr>
-              <a:t>1.33x</a:t>
+              <a:t>1.10x</a:t>
             </a:r>
           </a:p>
         </p:txBody>
@@ -9671,7 +9671,7 @@
         <p:spPr>
           <a:xfrm>
             <a:off x="7607808" y="4892040"/>
-            <a:ext cx="4069080" cy="941832"/>
+            <a:ext cx="4069080" cy="1024128"/>
           </a:xfrm>
           <a:prstGeom prst="rect">
             <a:avLst/>
@@ -9716,7 +9716,7 @@
         <p:spPr>
           <a:xfrm>
             <a:off x="7607808" y="4892040"/>
-            <a:ext cx="54864" cy="941832"/>
+            <a:ext cx="54864" cy="1024128"/>
           </a:xfrm>
           <a:prstGeom prst="rect">
             <a:avLst/>
@@ -9800,7 +9800,7 @@
         <p:spPr>
           <a:xfrm>
             <a:off x="7808976" y="5413248"/>
-            <a:ext cx="3739896" cy="301752"/>
+            <a:ext cx="3739896" cy="384048"/>
           </a:xfrm>
           <a:prstGeom prst="rect">
             <a:avLst/>
@@ -9825,7 +9825,7 @@
                 </a:solidFill>
                 <a:latin typeface="Aptos"/>
               </a:rPr>
-              <a:t>Both cost gates pass, but Wolf trailed equal weight by 1.06% per year and the difference was not significant (p=0.734).</a:t>
+              <a:t>Both cost gates pass, but Wolf trailed equal weight by 2.43% per year in this 60-month sample (p=0.550).</a:t>
             </a:r>
           </a:p>
         </p:txBody>
@@ -13796,7 +13796,7 @@
       </p:sp>
       <p:sp>
         <p:nvSpPr>
-          <p:cNvPr id="17" name="Text: Observed PIT evidence is incomplete, and Wolf lagg"/>
+          <p:cNvPr id="17" name="Text: Observed PIT evidence is incomplete, and Wolf trai"/>
           <p:cNvSpPr txBox="1"/>
           <p:nvPr/>
         </p:nvSpPr>
@@ -13828,7 +13828,7 @@
                 </a:solidFill>
                 <a:latin typeface="Aptos"/>
               </a:rPr>
-              <a:t>Observed PIT evidence is incomplete, and Wolf lagged equal weight by 1.06% per year in this 60-month sample (p=0.734).</a:t>
+              <a:t>Observed PIT evidence is incomplete, and Wolf trailed equal weight by 2.43% per year in this 60-month sample (p=0.550).</a:t>
             </a:r>
           </a:p>
         </p:txBody>
@@ -16448,7 +16448,7 @@
       </p:sp>
       <p:sp>
         <p:nvSpPr>
-          <p:cNvPr id="3" name="Text: Delistings improved; observed historical availabil"/>
+          <p:cNvPr id="3" name="Text: Bloomberg vintages expanded; survivorship-clean me"/>
           <p:cNvSpPr txBox="1"/>
           <p:nvPr/>
         </p:nvSpPr>
@@ -16480,7 +16480,7 @@
                 </a:solidFill>
                 <a:latin typeface="Aptos"/>
               </a:rPr>
-              <a:t>Delistings improved; observed historical availability remains the main gap.</a:t>
+              <a:t>Bloomberg vintages expanded; survivorship-clean membership remains the main gap.</a:t>
             </a:r>
           </a:p>
         </p:txBody>
@@ -16610,7 +16610,7 @@
       </p:sp>
       <p:sp>
         <p:nvSpPr>
-          <p:cNvPr id="7" name="Text: Universe, walk-forward manifest and PIT evidence c"/>
+          <p:cNvPr id="7" name="Text: Universe, walk-forward manifest and aggregate PIT "/>
           <p:cNvSpPr txBox="1"/>
           <p:nvPr/>
         </p:nvSpPr>
@@ -16642,7 +16642,7 @@
                 </a:solidFill>
                 <a:latin typeface="Aptos"/>
               </a:rPr>
-              <a:t>Universe, walk-forward manifest and PIT evidence coverage</a:t>
+              <a:t>Universe, walk-forward manifest and aggregate PIT coverage</a:t>
             </a:r>
           </a:p>
         </p:txBody>
@@ -17075,7 +17075,7 @@
       </p:sp>
       <p:sp>
         <p:nvSpPr>
-          <p:cNvPr id="18" name="Text: 156,960"/>
+          <p:cNvPr id="18" name="Text: 181,664"/>
           <p:cNvSpPr txBox="1"/>
           <p:nvPr/>
         </p:nvSpPr>
@@ -17107,7 +17107,7 @@
                 </a:solidFill>
                 <a:latin typeface="Aptos Display"/>
               </a:rPr>
-              <a:t>156,960</a:t>
+              <a:t>181,664</a:t>
             </a:r>
           </a:p>
         </p:txBody>
@@ -17243,7 +17243,7 @@
       </p:sp>
       <p:sp>
         <p:nvSpPr>
-          <p:cNvPr id="22" name="Text: 59,183"/>
+          <p:cNvPr id="22" name="Text: 25,240"/>
           <p:cNvSpPr txBox="1"/>
           <p:nvPr/>
         </p:nvSpPr>
@@ -17275,14 +17275,14 @@
                 </a:solidFill>
                 <a:latin typeface="Aptos Display"/>
               </a:rPr>
-              <a:t>59,183</a:t>
-            </a:r>
-          </a:p>
-        </p:txBody>
-      </p:sp>
-      <p:sp>
-        <p:nvSpPr>
-          <p:cNvPr id="23" name="Text: delistings archived"/>
+              <a:t>25,240</a:t>
+            </a:r>
+          </a:p>
+        </p:txBody>
+      </p:sp>
+      <p:sp>
+        <p:nvSpPr>
+          <p:cNvPr id="23" name="Text: Bloomberg fundamental vintages"/>
           <p:cNvSpPr txBox="1"/>
           <p:nvPr/>
         </p:nvSpPr>
@@ -17314,7 +17314,7 @@
                 </a:solidFill>
                 <a:latin typeface="Aptos"/>
               </a:rPr>
-              <a:t>delistings archived</a:t>
+              <a:t>Bloomberg fundamental vintages</a:t>
             </a:r>
           </a:p>
         </p:txBody>
@@ -18243,7 +18243,7 @@
                         </a:defRPr>
                       </a:pPr>
                       <a:r>
-                        <a:t>7,081</a:t>
+                        <a:t>32,321</a:t>
                       </a:r>
                     </a:p>
                   </a:txBody>
@@ -18539,7 +18539,7 @@
                         </a:defRPr>
                       </a:pPr>
                       <a:r>
-                        <a:t>0</a:t>
+                        <a:t>19</a:t>
                       </a:r>
                     </a:p>
                   </a:txBody>
@@ -18670,7 +18670,7 @@
       </p:sp>
       <p:sp>
         <p:nvSpPr>
-          <p:cNvPr id="28" name="Text: Provider outcome: EODHD added 59,183 delistings; N"/>
+          <p:cNvPr id="28" name="Text: Bloomberg checkpoint and publication boundary: 25,"/>
           <p:cNvSpPr txBox="1"/>
           <p:nvPr/>
         </p:nvSpPr>
@@ -18702,7 +18702,7 @@
                 </a:solidFill>
                 <a:latin typeface="Aptos"/>
               </a:rPr>
-              <a:t>Provider outcome: EODHD added 59,183 delistings; Nasdaq entitlement yielded five usable rows; Beam was unavailable; SEC blocked this runner. Unavailable history is never treated as observed.</a:t>
+              <a:t>Bloomberg checkpoint and publication boundary: 25,240 fundamental, 694,246 market-cap and 151,659 corporate-action vintages are stored locally. Daily capacity paused the remaining snapshots at a durable checkpoint; only aggregate counts are published.</a:t>
             </a:r>
           </a:p>
         </p:txBody>
@@ -19440,7 +19440,7 @@
       </p:sp>
       <p:sp>
         <p:nvSpPr>
-          <p:cNvPr id="19" name="Text: target per name"/>
+          <p:cNvPr id="19" name="Text: maximum name"/>
           <p:cNvSpPr txBox="1"/>
           <p:nvPr/>
         </p:nvSpPr>
@@ -19472,7 +19472,7 @@
                 </a:solidFill>
                 <a:latin typeface="Aptos"/>
               </a:rPr>
-              <a:t>target per name</a:t>
+              <a:t>maximum name</a:t>
             </a:r>
           </a:p>
         </p:txBody>
@@ -19608,7 +19608,7 @@
       </p:sp>
       <p:sp>
         <p:nvSpPr>
-          <p:cNvPr id="23" name="Text: target holdings"/>
+          <p:cNvPr id="23" name="Text: equity holdings"/>
           <p:cNvSpPr txBox="1"/>
           <p:nvPr/>
         </p:nvSpPr>
@@ -19640,7 +19640,7 @@
                 </a:solidFill>
                 <a:latin typeface="Aptos"/>
               </a:rPr>
-              <a:t>target holdings</a:t>
+              <a:t>equity holdings</a:t>
             </a:r>
           </a:p>
         </p:txBody>
@@ -20219,7 +20219,7 @@
                         </a:defRPr>
                       </a:pPr>
                       <a:r>
-                        <a:t>0823.HK</a:t>
+                        <a:t>0728.HK</a:t>
                       </a:r>
                     </a:p>
                   </a:txBody>
@@ -20243,7 +20243,7 @@
                         </a:defRPr>
                       </a:pPr>
                       <a:r>
-                        <a:t>Link Real Estate Investment T</a:t>
+                        <a:t>China Telecom</a:t>
                       </a:r>
                     </a:p>
                   </a:txBody>
@@ -20341,7 +20341,7 @@
                         </a:defRPr>
                       </a:pPr>
                       <a:r>
-                        <a:t>3988.HK</a:t>
+                        <a:t>1113.HK</a:t>
                       </a:r>
                     </a:p>
                   </a:txBody>
@@ -20365,7 +20365,7 @@
                         </a:defRPr>
                       </a:pPr>
                       <a:r>
-                        <a:t>Bank of China Ltd H</a:t>
+                        <a:t>CK Asset Holdings Ltd</a:t>
                       </a:r>
                     </a:p>
                   </a:txBody>
@@ -20463,7 +20463,7 @@
                         </a:defRPr>
                       </a:pPr>
                       <a:r>
-                        <a:t>600018.SHG</a:t>
+                        <a:t>3988.HK</a:t>
                       </a:r>
                     </a:p>
                   </a:txBody>
@@ -20487,7 +20487,7 @@
                         </a:defRPr>
                       </a:pPr>
                       <a:r>
-                        <a:t>Shanghai International Port G</a:t>
+                        <a:t>Bank of China Ltd H</a:t>
                       </a:r>
                     </a:p>
                   </a:txBody>
@@ -20511,7 +20511,7 @@
                         </a:defRPr>
                       </a:pPr>
                       <a:r>
-                        <a:t>Mainland China</a:t>
+                        <a:t>Hong Kong</a:t>
                       </a:r>
                     </a:p>
                   </a:txBody>
@@ -20585,7 +20585,7 @@
                         </a:defRPr>
                       </a:pPr>
                       <a:r>
-                        <a:t>600036.SHG</a:t>
+                        <a:t>600018.SHG</a:t>
                       </a:r>
                     </a:p>
                   </a:txBody>
@@ -20609,7 +20609,7 @@
                         </a:defRPr>
                       </a:pPr>
                       <a:r>
-                        <a:t>China Merchants Bank Co Ltd</a:t>
+                        <a:t>Shanghai International Port G</a:t>
                       </a:r>
                     </a:p>
                   </a:txBody>
@@ -20707,7 +20707,7 @@
                         </a:defRPr>
                       </a:pPr>
                       <a:r>
-                        <a:t>601816.SHG</a:t>
+                        <a:t>600036.SHG</a:t>
                       </a:r>
                     </a:p>
                   </a:txBody>
@@ -20731,7 +20731,7 @@
                         </a:defRPr>
                       </a:pPr>
                       <a:r>
-                        <a:t>Beijing-Shanghai High Speed R</a:t>
+                        <a:t>China Merchants Bank Co Ltd</a:t>
                       </a:r>
                     </a:p>
                   </a:txBody>
@@ -20829,7 +20829,7 @@
                         </a:defRPr>
                       </a:pPr>
                       <a:r>
-                        <a:t>601818.SHG</a:t>
+                        <a:t>601816.SHG</a:t>
                       </a:r>
                     </a:p>
                   </a:txBody>
@@ -20853,7 +20853,7 @@
                         </a:defRPr>
                       </a:pPr>
                       <a:r>
-                        <a:t>China Everbright Bank Co Ltd</a:t>
+                        <a:t>Beijing-Shanghai High Speed R</a:t>
                       </a:r>
                     </a:p>
                   </a:txBody>
@@ -20951,7 +20951,7 @@
                         </a:defRPr>
                       </a:pPr>
                       <a:r>
-                        <a:t>AD.AS</a:t>
+                        <a:t>601818.SHG</a:t>
                       </a:r>
                     </a:p>
                   </a:txBody>
@@ -20975,7 +20975,7 @@
                         </a:defRPr>
                       </a:pPr>
                       <a:r>
-                        <a:t>Koninklijke Ahold Delhaize NV</a:t>
+                        <a:t>China Everbright Bank Co Ltd</a:t>
                       </a:r>
                     </a:p>
                   </a:txBody>
@@ -20999,7 +20999,7 @@
                         </a:defRPr>
                       </a:pPr>
                       <a:r>
-                        <a:t>EU ex-DACH</a:t>
+                        <a:t>Mainland China</a:t>
                       </a:r>
                     </a:p>
                   </a:txBody>
@@ -21073,7 +21073,7 @@
                         </a:defRPr>
                       </a:pPr>
                       <a:r>
-                        <a:t>ALV.XETRA</a:t>
+                        <a:t>AD.AS</a:t>
                       </a:r>
                     </a:p>
                   </a:txBody>
@@ -21097,7 +21097,7 @@
                         </a:defRPr>
                       </a:pPr>
                       <a:r>
-                        <a:t>Allianz SE VNA O.N.</a:t>
+                        <a:t>Koninklijke Ahold Delhaize NV</a:t>
                       </a:r>
                     </a:p>
                   </a:txBody>
@@ -21121,7 +21121,7 @@
                         </a:defRPr>
                       </a:pPr>
                       <a:r>
-                        <a:t>DACH</a:t>
+                        <a:t>EU ex-DACH</a:t>
                       </a:r>
                     </a:p>
                   </a:txBody>
@@ -21346,7 +21346,7 @@
                         </a:defRPr>
                       </a:pPr>
                       <a:r>
-                        <a:t>CS.PA</a:t>
+                        <a:t>ALV.XETRA</a:t>
                       </a:r>
                     </a:p>
                   </a:txBody>
@@ -21370,7 +21370,7 @@
                         </a:defRPr>
                       </a:pPr>
                       <a:r>
-                        <a:t>AXA SA</a:t>
+                        <a:t>Allianz SE VNA O.N.</a:t>
                       </a:r>
                     </a:p>
                   </a:txBody>
@@ -21394,7 +21394,7 @@
                         </a:defRPr>
                       </a:pPr>
                       <a:r>
-                        <a:t>EU ex-DACH</a:t>
+                        <a:t>DACH</a:t>
                       </a:r>
                     </a:p>
                   </a:txBody>
@@ -21468,7 +21468,7 @@
                         </a:defRPr>
                       </a:pPr>
                       <a:r>
-                        <a:t>ESSITY-B.ST</a:t>
+                        <a:t>CA.PA</a:t>
                       </a:r>
                     </a:p>
                   </a:txBody>
@@ -21492,7 +21492,7 @@
                         </a:defRPr>
                       </a:pPr>
                       <a:r>
-                        <a:t>Essity AB (publ)</a:t>
+                        <a:t>Carrefour SA</a:t>
                       </a:r>
                     </a:p>
                   </a:txBody>
@@ -21590,7 +21590,7 @@
                         </a:defRPr>
                       </a:pPr>
                       <a:r>
-                        <a:t>HEN3.XETRA</a:t>
+                        <a:t>ELE.MC</a:t>
                       </a:r>
                     </a:p>
                   </a:txBody>
@@ -21614,7 +21614,7 @@
                         </a:defRPr>
                       </a:pPr>
                       <a:r>
-                        <a:t>Henkel AG &amp; Co. KGaA vz. (Pre</a:t>
+                        <a:t>Endesa SA</a:t>
                       </a:r>
                     </a:p>
                   </a:txBody>
@@ -21638,7 +21638,7 @@
                         </a:defRPr>
                       </a:pPr>
                       <a:r>
-                        <a:t>DACH</a:t>
+                        <a:t>EU ex-DACH</a:t>
                       </a:r>
                     </a:p>
                   </a:txBody>
@@ -21712,7 +21712,7 @@
                         </a:defRPr>
                       </a:pPr>
                       <a:r>
-                        <a:t>LI.PA</a:t>
+                        <a:t>ESSITY-B.ST</a:t>
                       </a:r>
                     </a:p>
                   </a:txBody>
@@ -21736,7 +21736,7 @@
                         </a:defRPr>
                       </a:pPr>
                       <a:r>
-                        <a:t>Klepierre SA</a:t>
+                        <a:t>Essity AB (publ)</a:t>
                       </a:r>
                     </a:p>
                   </a:txBody>
@@ -21834,7 +21834,7 @@
                         </a:defRPr>
                       </a:pPr>
                       <a:r>
-                        <a:t>MCD.US</a:t>
+                        <a:t>HEN3.XETRA</a:t>
                       </a:r>
                     </a:p>
                   </a:txBody>
@@ -21858,7 +21858,7 @@
                         </a:defRPr>
                       </a:pPr>
                       <a:r>
-                        <a:t>McDonalds Corporation</a:t>
+                        <a:t>Henkel AG &amp; Co. KGaA vz. (Pre</a:t>
                       </a:r>
                     </a:p>
                   </a:txBody>
@@ -21882,7 +21882,7 @@
                         </a:defRPr>
                       </a:pPr>
                       <a:r>
-                        <a:t>US</a:t>
+                        <a:t>DACH</a:t>
                       </a:r>
                     </a:p>
                   </a:txBody>
@@ -21956,7 +21956,7 @@
                         </a:defRPr>
                       </a:pPr>
                       <a:r>
-                        <a:t>ORA.PA</a:t>
+                        <a:t>HIG.US</a:t>
                       </a:r>
                     </a:p>
                   </a:txBody>
@@ -21980,7 +21980,7 @@
                         </a:defRPr>
                       </a:pPr>
                       <a:r>
-                        <a:t>Orange S.A.</a:t>
+                        <a:t>Hartford Financial Services G</a:t>
                       </a:r>
                     </a:p>
                   </a:txBody>
@@ -22004,7 +22004,7 @@
                         </a:defRPr>
                       </a:pPr>
                       <a:r>
-                        <a:t>EU ex-DACH</a:t>
+                        <a:t>US</a:t>
                       </a:r>
                     </a:p>
                   </a:txBody>
@@ -22078,7 +22078,7 @@
                         </a:defRPr>
                       </a:pPr>
                       <a:r>
-                        <a:t>PG.US</a:t>
+                        <a:t>IMB.LSE</a:t>
                       </a:r>
                     </a:p>
                   </a:txBody>
@@ -22102,7 +22102,7 @@
                         </a:defRPr>
                       </a:pPr>
                       <a:r>
-                        <a:t>Procter &amp; Gamble Company</a:t>
+                        <a:t>Imperial Brands PLC</a:t>
                       </a:r>
                     </a:p>
                   </a:txBody>
@@ -22126,7 +22126,7 @@
                         </a:defRPr>
                       </a:pPr>
                       <a:r>
-                        <a:t>US</a:t>
+                        <a:t>UK</a:t>
                       </a:r>
                     </a:p>
                   </a:txBody>
@@ -22200,7 +22200,7 @@
                         </a:defRPr>
                       </a:pPr>
                       <a:r>
-                        <a:t>SBRY.LSE</a:t>
+                        <a:t>ORA.PA</a:t>
                       </a:r>
                     </a:p>
                   </a:txBody>
@@ -22224,7 +22224,7 @@
                         </a:defRPr>
                       </a:pPr>
                       <a:r>
-                        <a:t>J Sainsbury PLC</a:t>
+                        <a:t>Orange S.A.</a:t>
                       </a:r>
                     </a:p>
                   </a:txBody>
@@ -22248,7 +22248,7 @@
                         </a:defRPr>
                       </a:pPr>
                       <a:r>
-                        <a:t>UK</a:t>
+                        <a:t>EU ex-DACH</a:t>
                       </a:r>
                     </a:p>
                   </a:txBody>
@@ -22322,7 +22322,7 @@
                         </a:defRPr>
                       </a:pPr>
                       <a:r>
-                        <a:t>SHEL.US</a:t>
+                        <a:t>SHELL.AS</a:t>
                       </a:r>
                     </a:p>
                   </a:txBody>
@@ -22346,7 +22346,7 @@
                         </a:defRPr>
                       </a:pPr>
                       <a:r>
-                        <a:t>Shell PLC ADR</a:t>
+                        <a:t>Shell PLC</a:t>
                       </a:r>
                     </a:p>
                   </a:txBody>
@@ -22370,7 +22370,7 @@
                         </a:defRPr>
                       </a:pPr>
                       <a:r>
-                        <a:t>US</a:t>
+                        <a:t>EU ex-DACH</a:t>
                       </a:r>
                     </a:p>
                   </a:txBody>
@@ -22960,7 +22960,7 @@
               </a:defRPr>
             </a:pPr>
             <a:r>
-              <a:t>• 20 holdings at 5% each</a:t>
+              <a:t>• 20 equities at no more than 5.0% each</a:t>
             </a:r>
           </a:p>
           <a:p>
@@ -22979,7 +22979,7 @@
               </a:defRPr>
             </a:pPr>
             <a:r>
-              <a:t>• No sector above 25%</a:t>
+              <a:t>• 0% cash reserve</a:t>
             </a:r>
           </a:p>
           <a:p>
@@ -22998,7 +22998,7 @@
               </a:defRPr>
             </a:pPr>
             <a:r>
-              <a:t>• No country above 30%</a:t>
+              <a:t>• No sector above 25%</a:t>
             </a:r>
           </a:p>
           <a:p>
@@ -23017,7 +23017,7 @@
               </a:defRPr>
             </a:pPr>
             <a:r>
-              <a:t>• No region or currency above 40%</a:t>
+              <a:t>• No country above 30%</a:t>
             </a:r>
           </a:p>
           <a:p>
@@ -23036,7 +23036,7 @@
               </a:defRPr>
             </a:pPr>
             <a:r>
-              <a:t>• One listing per issuer</a:t>
+              <a:t>• No region or currency above 40%</a:t>
             </a:r>
           </a:p>
           <a:p>
@@ -23055,7 +23055,7 @@
               </a:defRPr>
             </a:pPr>
             <a:r>
-              <a:t>• No quarantined price history</a:t>
+              <a:t>• One listing per issuer</a:t>
             </a:r>
           </a:p>
         </p:txBody>
@@ -23191,7 +23191,7 @@
       </p:sp>
       <p:sp>
         <p:nvSpPr>
-          <p:cNvPr id="14" name="Text: Mainland China 30%; EU ex-DACH 25%; Financials and"/>
+          <p:cNvPr id="14" name="Text: EU ex-DACH 30%; Consumer Staples 25%. Cash is excl"/>
           <p:cNvSpPr txBox="1"/>
           <p:nvPr/>
         </p:nvSpPr>
@@ -23223,7 +23223,7 @@
                 </a:solidFill>
                 <a:latin typeface="Aptos"/>
               </a:rPr>
-              <a:t>Mainland China 30%; EU ex-DACH 25%; Financials and Consumer Staples 25% each.</a:t>
+              <a:t>EU ex-DACH 30%; Consumer Staples 25%. Cash is excluded from equity exposure caps.</a:t>
             </a:r>
           </a:p>
         </p:txBody>
@@ -23680,7 +23680,7 @@
                         </a:defRPr>
                       </a:pPr>
                       <a:r>
-                        <a:t>14.7%</a:t>
+                        <a:t>14.9%</a:t>
                       </a:r>
                     </a:p>
                   </a:txBody>
@@ -23704,7 +23704,7 @@
                         </a:defRPr>
                       </a:pPr>
                       <a:r>
-                        <a:t>-27.4%</a:t>
+                        <a:t>-24.5%</a:t>
                       </a:r>
                     </a:p>
                   </a:txBody>
@@ -23728,7 +23728,7 @@
                         </a:defRPr>
                       </a:pPr>
                       <a:r>
-                        <a:t>3.2%</a:t>
+                        <a:t>3.4%</a:t>
                       </a:r>
                     </a:p>
                   </a:txBody>
@@ -23802,7 +23802,7 @@
                         </a:defRPr>
                       </a:pPr>
                       <a:r>
-                        <a:t>12.5%</a:t>
+                        <a:t>12.7%</a:t>
                       </a:r>
                     </a:p>
                   </a:txBody>
@@ -23826,7 +23826,7 @@
                         </a:defRPr>
                       </a:pPr>
                       <a:r>
-                        <a:t>-9.5%</a:t>
+                        <a:t>-11.3%</a:t>
                       </a:r>
                     </a:p>
                   </a:txBody>
@@ -23850,7 +23850,7 @@
                         </a:defRPr>
                       </a:pPr>
                       <a:r>
-                        <a:t>4.4%</a:t>
+                        <a:t>4.7%</a:t>
                       </a:r>
                     </a:p>
                   </a:txBody>
@@ -23924,7 +23924,7 @@
                         </a:defRPr>
                       </a:pPr>
                       <a:r>
-                        <a:t>10.9%</a:t>
+                        <a:t>11.1%</a:t>
                       </a:r>
                     </a:p>
                   </a:txBody>
@@ -23948,7 +23948,7 @@
                         </a:defRPr>
                       </a:pPr>
                       <a:r>
-                        <a:t>-9.8%</a:t>
+                        <a:t>-14.5%</a:t>
                       </a:r>
                     </a:p>
                   </a:txBody>
@@ -23972,7 +23972,7 @@
                         </a:defRPr>
                       </a:pPr>
                       <a:r>
-                        <a:t>3.5%</a:t>
+                        <a:t>3.3%</a:t>
                       </a:r>
                     </a:p>
                   </a:txBody>
@@ -24046,7 +24046,7 @@
                         </a:defRPr>
                       </a:pPr>
                       <a:r>
-                        <a:t>11.3%</a:t>
+                        <a:t>11.7%</a:t>
                       </a:r>
                     </a:p>
                   </a:txBody>
@@ -24070,7 +24070,7 @@
                         </a:defRPr>
                       </a:pPr>
                       <a:r>
-                        <a:t>-5.6%</a:t>
+                        <a:t>-7.6%</a:t>
                       </a:r>
                     </a:p>
                   </a:txBody>
@@ -24094,7 +24094,7 @@
                         </a:defRPr>
                       </a:pPr>
                       <a:r>
-                        <a:t>4.2%</a:t>
+                        <a:t>4.6%</a:t>
                       </a:r>
                     </a:p>
                   </a:txBody>
@@ -24168,7 +24168,7 @@
                         </a:defRPr>
                       </a:pPr>
                       <a:r>
-                        <a:t>11.1%</a:t>
+                        <a:t>11.5%</a:t>
                       </a:r>
                     </a:p>
                   </a:txBody>
@@ -24192,7 +24192,7 @@
                         </a:defRPr>
                       </a:pPr>
                       <a:r>
-                        <a:t>-5.1%</a:t>
+                        <a:t>-7.1%</a:t>
                       </a:r>
                     </a:p>
                   </a:txBody>
@@ -24216,7 +24216,7 @@
                         </a:defRPr>
                       </a:pPr>
                       <a:r>
-                        <a:t>4.3%</a:t>
+                        <a:t>4.6%</a:t>
                       </a:r>
                     </a:p>
                   </a:txBody>
@@ -24290,7 +24290,7 @@
                         </a:defRPr>
                       </a:pPr>
                       <a:r>
-                        <a:t>13.6%</a:t>
+                        <a:t>14.3%</a:t>
                       </a:r>
                     </a:p>
                   </a:txBody>
@@ -24314,7 +24314,7 @@
                         </a:defRPr>
                       </a:pPr>
                       <a:r>
-                        <a:t>-13.5%</a:t>
+                        <a:t>-15.6%</a:t>
                       </a:r>
                     </a:p>
                   </a:txBody>
@@ -24338,7 +24338,7 @@
                         </a:defRPr>
                       </a:pPr>
                       <a:r>
-                        <a:t>5.0%</a:t>
+                        <a:t>5.5%</a:t>
                       </a:r>
                     </a:p>
                   </a:txBody>
@@ -24412,7 +24412,7 @@
                         </a:defRPr>
                       </a:pPr>
                       <a:r>
-                        <a:t>13.0%</a:t>
+                        <a:t>13.3%</a:t>
                       </a:r>
                     </a:p>
                   </a:txBody>
@@ -24436,7 +24436,7 @@
                         </a:defRPr>
                       </a:pPr>
                       <a:r>
-                        <a:t>-11.3%</a:t>
+                        <a:t>-13.0%</a:t>
                       </a:r>
                     </a:p>
                   </a:txBody>
@@ -24460,7 +24460,7 @@
                         </a:defRPr>
                       </a:pPr>
                       <a:r>
-                        <a:t>4.7%</a:t>
+                        <a:t>5.2%</a:t>
                       </a:r>
                     </a:p>
                   </a:txBody>
@@ -25355,7 +25355,7 @@
       </p:sp>
       <p:sp>
         <p:nvSpPr>
-          <p:cNvPr id="12" name="Text: $186.1m grows to $355.3m; net PnL is $169.3m after"/>
+          <p:cNvPr id="12" name="Text: $186.1m grows to $347.2m; net PnL is $161.2m after"/>
           <p:cNvSpPr txBox="1"/>
           <p:nvPr/>
         </p:nvSpPr>
@@ -25387,7 +25387,7 @@
                 </a:solidFill>
                 <a:latin typeface="Aptos"/>
               </a:rPr>
-              <a:t>$186.1m grows to $355.3m; net PnL is $169.3m after trading costs and before the bank fee.</a:t>
+              <a:t>$186.1m grows to $347.2m; net PnL is $161.2m after trading costs and before the bank fee.</a:t>
             </a:r>
           </a:p>
         </p:txBody>
@@ -25429,7 +25429,7 @@
               </a:defRPr>
             </a:pPr>
             <a:r>
-              <a:t>• Net annualised return: 13.8%</a:t>
+              <a:t>• Net annualised return: 13.3%</a:t>
             </a:r>
           </a:p>
           <a:p>
@@ -25448,7 +25448,7 @@
               </a:defRPr>
             </a:pPr>
             <a:r>
-              <a:t>• Sharpe ratio: 1.26</a:t>
+              <a:t>• Sharpe ratio: 1.32</a:t>
             </a:r>
           </a:p>
           <a:p>
@@ -25467,7 +25467,7 @@
               </a:defRPr>
             </a:pPr>
             <a:r>
-              <a:t>• Maximum drawdown: -13.0%</a:t>
+              <a:t>• Maximum drawdown: -10.1%</a:t>
             </a:r>
           </a:p>
           <a:p>
@@ -25486,7 +25486,7 @@
               </a:defRPr>
             </a:pPr>
             <a:r>
-              <a:t>• Positive months: 65.0%</a:t>
+              <a:t>• Positive months: 63.3%</a:t>
             </a:r>
           </a:p>
         </p:txBody>
@@ -25500,7 +25500,7 @@
         <p:spPr>
           <a:xfrm>
             <a:off x="8339327" y="4956048"/>
-            <a:ext cx="3337560" cy="960120"/>
+            <a:ext cx="3337560" cy="1188720"/>
           </a:xfrm>
           <a:prstGeom prst="rect">
             <a:avLst/>
@@ -25545,7 +25545,7 @@
         <p:spPr>
           <a:xfrm>
             <a:off x="8339327" y="4956048"/>
-            <a:ext cx="54864" cy="960120"/>
+            <a:ext cx="54864" cy="1188720"/>
           </a:xfrm>
           <a:prstGeom prst="rect">
             <a:avLst/>
@@ -25629,7 +25629,7 @@
         <p:spPr>
           <a:xfrm>
             <a:off x="8540496" y="5477256"/>
-            <a:ext cx="3008376" cy="320040"/>
+            <a:ext cx="3008376" cy="548640"/>
           </a:xfrm>
           <a:prstGeom prst="rect">
             <a:avLst/>
@@ -25958,7 +25958,7 @@
         <p:spPr>
           <a:xfrm>
             <a:off x="8302752" y="1426464"/>
-            <a:ext cx="3374136" cy="1143000"/>
+            <a:ext cx="3374136" cy="1197864"/>
           </a:xfrm>
           <a:prstGeom prst="rect">
             <a:avLst/>
@@ -26003,7 +26003,7 @@
         <p:spPr>
           <a:xfrm>
             <a:off x="8302752" y="1426464"/>
-            <a:ext cx="54864" cy="1143000"/>
+            <a:ext cx="54864" cy="1197864"/>
           </a:xfrm>
           <a:prstGeom prst="rect">
             <a:avLst/>
@@ -26080,14 +26080,14 @@
       </p:sp>
       <p:sp>
         <p:nvSpPr>
-          <p:cNvPr id="12" name="Text: Wolf Sharpe was 1.26 and drawdown was 13.0%, bette"/>
+          <p:cNvPr id="12" name="Text: Wolf Sharpe was 1.32 and drawdown was 10.1%, bette"/>
           <p:cNvSpPr txBox="1"/>
           <p:nvPr/>
         </p:nvSpPr>
         <p:spPr>
           <a:xfrm>
             <a:off x="8503920" y="1947672"/>
-            <a:ext cx="3044952" cy="502920"/>
+            <a:ext cx="3044952" cy="557784"/>
           </a:xfrm>
           <a:prstGeom prst="rect">
             <a:avLst/>
@@ -26112,7 +26112,7 @@
                 </a:solidFill>
                 <a:latin typeface="Aptos"/>
               </a:rPr>
-              <a:t>Wolf Sharpe was 1.26 and drawdown was 13.0%, better than both simple controls on these risk measures.</a:t>
+              <a:t>Wolf Sharpe was 1.32 and drawdown was 10.1%, better than both simple controls on these risk measures.</a:t>
             </a:r>
           </a:p>
         </p:txBody>
@@ -26126,7 +26126,7 @@
         <p:spPr>
           <a:xfrm>
             <a:off x="8302752" y="2889504"/>
-            <a:ext cx="3374136" cy="1143000"/>
+            <a:ext cx="3374136" cy="1197864"/>
           </a:xfrm>
           <a:prstGeom prst="rect">
             <a:avLst/>
@@ -26171,7 +26171,7 @@
         <p:spPr>
           <a:xfrm>
             <a:off x="8302752" y="2889504"/>
-            <a:ext cx="54864" cy="1143000"/>
+            <a:ext cx="54864" cy="1197864"/>
           </a:xfrm>
           <a:prstGeom prst="rect">
             <a:avLst/>
@@ -26248,14 +26248,14 @@
       </p:sp>
       <p:sp>
         <p:nvSpPr>
-          <p:cNvPr id="16" name="Text: Equal weight returned 14.88% versus Wolf at 13.81%"/>
+          <p:cNvPr id="16" name="Text: Equal weight returned 15.72% versus Wolf at 13.29%"/>
           <p:cNvSpPr txBox="1"/>
           <p:nvPr/>
         </p:nvSpPr>
         <p:spPr>
           <a:xfrm>
             <a:off x="8503920" y="3410712"/>
-            <a:ext cx="3044952" cy="502920"/>
+            <a:ext cx="3044952" cy="557784"/>
           </a:xfrm>
           <a:prstGeom prst="rect">
             <a:avLst/>
@@ -26280,7 +26280,7 @@
                 </a:solidFill>
                 <a:latin typeface="Aptos"/>
               </a:rPr>
-              <a:t>Equal weight returned 14.88% versus Wolf at 13.81%. The model did not beat the simplest control on net return.</a:t>
+              <a:t>Equal weight returned 15.72% versus Wolf at 13.29%. The model did not beat the simplest control on net return.</a:t>
             </a:r>
           </a:p>
         </p:txBody>
@@ -26294,7 +26294,7 @@
         <p:spPr>
           <a:xfrm>
             <a:off x="8302752" y="4352544"/>
-            <a:ext cx="3374136" cy="1143000"/>
+            <a:ext cx="3374136" cy="1197864"/>
           </a:xfrm>
           <a:prstGeom prst="rect">
             <a:avLst/>
@@ -26339,7 +26339,7 @@
         <p:spPr>
           <a:xfrm>
             <a:off x="8302752" y="4352544"/>
-            <a:ext cx="54864" cy="1143000"/>
+            <a:ext cx="54864" cy="1197864"/>
           </a:xfrm>
           <a:prstGeom prst="rect">
             <a:avLst/>
@@ -26423,7 +26423,7 @@
         <p:spPr>
           <a:xfrm>
             <a:off x="8503920" y="4873752"/>
-            <a:ext cx="3044952" cy="502920"/>
+            <a:ext cx="3044952" cy="557784"/>
           </a:xfrm>
           <a:prstGeom prst="rect">
             <a:avLst/>

</xml_diff>